<commit_message>
added miles to geolocation, presentation update
</commit_message>
<xml_diff>
--- a/presentation/Olist E-Commerce Analysis.pptx
+++ b/presentation/Olist E-Commerce Analysis.pptx
@@ -9732,7 +9732,7 @@
           <a:p>
             <a:fld id="{B2374077-9B34-4FA8-8422-634E903F67E1}" type="datetimeFigureOut">
               <a:rPr lang="en-US" smtClean="0"/>
-              <a:t>4/9/2026</a:t>
+              <a:t>4/15/2026</a:t>
             </a:fld>
             <a:endParaRPr lang="en-US"/>
           </a:p>
@@ -9939,7 +9939,7 @@
           <a:p>
             <a:fld id="{B2374077-9B34-4FA8-8422-634E903F67E1}" type="datetimeFigureOut">
               <a:rPr lang="en-US" smtClean="0"/>
-              <a:t>4/9/2026</a:t>
+              <a:t>4/15/2026</a:t>
             </a:fld>
             <a:endParaRPr lang="en-US"/>
           </a:p>
@@ -10119,7 +10119,7 @@
           <a:p>
             <a:fld id="{B2374077-9B34-4FA8-8422-634E903F67E1}" type="datetimeFigureOut">
               <a:rPr lang="en-US" smtClean="0"/>
-              <a:t>4/9/2026</a:t>
+              <a:t>4/15/2026</a:t>
             </a:fld>
             <a:endParaRPr lang="en-US"/>
           </a:p>
@@ -10324,7 +10324,7 @@
           <a:p>
             <a:fld id="{B2374077-9B34-4FA8-8422-634E903F67E1}" type="datetimeFigureOut">
               <a:rPr lang="en-US" smtClean="0"/>
-              <a:t>4/9/2026</a:t>
+              <a:t>4/15/2026</a:t>
             </a:fld>
             <a:endParaRPr lang="en-US"/>
           </a:p>
@@ -19236,7 +19236,7 @@
           <a:p>
             <a:fld id="{B2374077-9B34-4FA8-8422-634E903F67E1}" type="datetimeFigureOut">
               <a:rPr lang="en-US" smtClean="0"/>
-              <a:t>4/9/2026</a:t>
+              <a:t>4/15/2026</a:t>
             </a:fld>
             <a:endParaRPr lang="en-US"/>
           </a:p>
@@ -19510,7 +19510,7 @@
           <a:p>
             <a:fld id="{B2374077-9B34-4FA8-8422-634E903F67E1}" type="datetimeFigureOut">
               <a:rPr lang="en-US" smtClean="0"/>
-              <a:t>4/9/2026</a:t>
+              <a:t>4/15/2026</a:t>
             </a:fld>
             <a:endParaRPr lang="en-US"/>
           </a:p>
@@ -19908,7 +19908,7 @@
           <a:p>
             <a:fld id="{B2374077-9B34-4FA8-8422-634E903F67E1}" type="datetimeFigureOut">
               <a:rPr lang="en-US" smtClean="0"/>
-              <a:t>4/9/2026</a:t>
+              <a:t>4/15/2026</a:t>
             </a:fld>
             <a:endParaRPr lang="en-US"/>
           </a:p>
@@ -20026,7 +20026,7 @@
           <a:p>
             <a:fld id="{B2374077-9B34-4FA8-8422-634E903F67E1}" type="datetimeFigureOut">
               <a:rPr lang="en-US" smtClean="0"/>
-              <a:t>4/9/2026</a:t>
+              <a:t>4/15/2026</a:t>
             </a:fld>
             <a:endParaRPr lang="en-US"/>
           </a:p>
@@ -20121,7 +20121,7 @@
           <a:p>
             <a:fld id="{B2374077-9B34-4FA8-8422-634E903F67E1}" type="datetimeFigureOut">
               <a:rPr lang="en-US" smtClean="0"/>
-              <a:t>4/9/2026</a:t>
+              <a:t>4/15/2026</a:t>
             </a:fld>
             <a:endParaRPr lang="en-US"/>
           </a:p>
@@ -20411,7 +20411,7 @@
           <a:p>
             <a:fld id="{B2374077-9B34-4FA8-8422-634E903F67E1}" type="datetimeFigureOut">
               <a:rPr lang="en-US" smtClean="0"/>
-              <a:t>4/9/2026</a:t>
+              <a:t>4/15/2026</a:t>
             </a:fld>
             <a:endParaRPr lang="en-US"/>
           </a:p>
@@ -20691,7 +20691,7 @@
           <a:p>
             <a:fld id="{B2374077-9B34-4FA8-8422-634E903F67E1}" type="datetimeFigureOut">
               <a:rPr lang="en-US" smtClean="0"/>
-              <a:t>4/9/2026</a:t>
+              <a:t>4/15/2026</a:t>
             </a:fld>
             <a:endParaRPr lang="en-US"/>
           </a:p>
@@ -20941,7 +20941,7 @@
           <a:p>
             <a:fld id="{B2374077-9B34-4FA8-8422-634E903F67E1}" type="datetimeFigureOut">
               <a:rPr lang="en-US" smtClean="0"/>
-              <a:t>4/9/2026</a:t>
+              <a:t>4/15/2026</a:t>
             </a:fld>
             <a:endParaRPr lang="en-US"/>
           </a:p>
@@ -22473,14 +22473,14 @@
             <p:ph sz="half" idx="1"/>
             <p:extLst>
               <p:ext uri="{D42A27DB-BD31-4B8C-83A1-F6EECF244321}">
-                <p14:modId xmlns:p14="http://schemas.microsoft.com/office/powerpoint/2010/main" val="3138031114"/>
+                <p14:modId xmlns:p14="http://schemas.microsoft.com/office/powerpoint/2010/main" val="315209694"/>
               </p:ext>
             </p:extLst>
           </p:nvPr>
         </p:nvGraphicFramePr>
         <p:xfrm>
           <a:off x="1024128" y="1877078"/>
-          <a:ext cx="4885208" cy="4287520"/>
+          <a:ext cx="4885208" cy="4531360"/>
         </p:xfrm>
         <a:graphic>
           <a:graphicData uri="http://schemas.openxmlformats.org/drawingml/2006/table">
@@ -22587,7 +22587,7 @@
                         <a:rPr lang="en-US" sz="1600" dirty="0">
                           <a:latin typeface="+mj-lt"/>
                         </a:rPr>
-                        <a:t> Distance</a:t>
+                        <a:t> Distance (miles)</a:t>
                       </a:r>
                     </a:p>
                   </a:txBody>
@@ -22627,7 +22627,7 @@
                         <a:rPr lang="en-US" sz="1600" dirty="0">
                           <a:latin typeface="+mj-lt"/>
                         </a:rPr>
-                        <a:t> Freight Cost</a:t>
+                        <a:t> Freight Cost (R$)</a:t>
                       </a:r>
                     </a:p>
                   </a:txBody>
@@ -22721,7 +22721,7 @@
                           <a:ea typeface="Aptos" panose="020B0004020202020204" pitchFamily="34" charset="0"/>
                           <a:cs typeface="Times New Roman" panose="02020603050405020304" pitchFamily="18" charset="0"/>
                         </a:rPr>
-                        <a:t>6895</a:t>
+                        <a:t>6,895</a:t>
                       </a:r>
                     </a:p>
                   </a:txBody>
@@ -22748,7 +22748,7 @@
                           <a:ea typeface="Aptos" panose="020B0004020202020204" pitchFamily="34" charset="0"/>
                           <a:cs typeface="Times New Roman" panose="02020603050405020304" pitchFamily="18" charset="0"/>
                         </a:rPr>
-                        <a:t>18.2</a:t>
+                        <a:t>11</a:t>
                       </a:r>
                     </a:p>
                   </a:txBody>
@@ -22878,7 +22878,7 @@
                           <a:ea typeface="Aptos" panose="020B0004020202020204" pitchFamily="34" charset="0"/>
                           <a:cs typeface="Times New Roman" panose="02020603050405020304" pitchFamily="18" charset="0"/>
                         </a:rPr>
-                        <a:t>2396</a:t>
+                        <a:t>2,396</a:t>
                       </a:r>
                     </a:p>
                   </a:txBody>
@@ -22905,7 +22905,7 @@
                           <a:ea typeface="Aptos" panose="020B0004020202020204" pitchFamily="34" charset="0"/>
                           <a:cs typeface="Times New Roman" panose="02020603050405020304" pitchFamily="18" charset="0"/>
                         </a:rPr>
-                        <a:t>374.7</a:t>
+                        <a:t>233</a:t>
                       </a:r>
                     </a:p>
                   </a:txBody>
@@ -23017,7 +23017,7 @@
                           <a:ea typeface="Aptos" panose="020B0004020202020204" pitchFamily="34" charset="0"/>
                           <a:cs typeface="Times New Roman" panose="02020603050405020304" pitchFamily="18" charset="0"/>
                         </a:rPr>
-                        <a:t>1957</a:t>
+                        <a:t>1,957</a:t>
                       </a:r>
                     </a:p>
                   </a:txBody>
@@ -23044,7 +23044,7 @@
                           <a:ea typeface="Aptos" panose="020B0004020202020204" pitchFamily="34" charset="0"/>
                           <a:cs typeface="Times New Roman" panose="02020603050405020304" pitchFamily="18" charset="0"/>
                         </a:rPr>
-                        <a:t>313.0</a:t>
+                        <a:t>195</a:t>
                       </a:r>
                     </a:p>
                   </a:txBody>
@@ -23150,7 +23150,7 @@
                           <a:ea typeface="Aptos" panose="020B0004020202020204" pitchFamily="34" charset="0"/>
                           <a:cs typeface="Times New Roman" panose="02020603050405020304" pitchFamily="18" charset="0"/>
                         </a:rPr>
-                        <a:t>1063</a:t>
+                        <a:t>1,063</a:t>
                       </a:r>
                     </a:p>
                   </a:txBody>
@@ -23177,7 +23177,7 @@
                           <a:ea typeface="Aptos" panose="020B0004020202020204" pitchFamily="34" charset="0"/>
                           <a:cs typeface="Times New Roman" panose="02020603050405020304" pitchFamily="18" charset="0"/>
                         </a:rPr>
-                        <a:t>501.5</a:t>
+                        <a:t>312</a:t>
                       </a:r>
                     </a:p>
                   </a:txBody>
@@ -23325,7 +23325,7 @@
                           <a:ea typeface="Aptos" panose="020B0004020202020204" pitchFamily="34" charset="0"/>
                           <a:cs typeface="Times New Roman" panose="02020603050405020304" pitchFamily="18" charset="0"/>
                         </a:rPr>
-                        <a:t>623.7</a:t>
+                        <a:t>388</a:t>
                       </a:r>
                     </a:p>
                   </a:txBody>
@@ -23455,7 +23455,7 @@
                           <a:ea typeface="Aptos" panose="020B0004020202020204" pitchFamily="34" charset="0"/>
                           <a:cs typeface="Times New Roman" panose="02020603050405020304" pitchFamily="18" charset="0"/>
                         </a:rPr>
-                        <a:t>25.0</a:t>
+                        <a:t>16</a:t>
                       </a:r>
                     </a:p>
                   </a:txBody>
@@ -23585,7 +23585,7 @@
                           <a:ea typeface="Aptos" panose="020B0004020202020204" pitchFamily="34" charset="0"/>
                           <a:cs typeface="Times New Roman" panose="02020603050405020304" pitchFamily="18" charset="0"/>
                         </a:rPr>
-                        <a:t>89.2</a:t>
+                        <a:t>55</a:t>
                       </a:r>
                     </a:p>
                   </a:txBody>
@@ -23718,7 +23718,7 @@
                           <a:ea typeface="Aptos" panose="020B0004020202020204" pitchFamily="34" charset="0"/>
                           <a:cs typeface="Times New Roman" panose="02020603050405020304" pitchFamily="18" charset="0"/>
                         </a:rPr>
-                        <a:t>813.3</a:t>
+                        <a:t>505</a:t>
                       </a:r>
                     </a:p>
                   </a:txBody>
@@ -23851,7 +23851,7 @@
                           <a:ea typeface="Aptos" panose="020B0004020202020204" pitchFamily="34" charset="0"/>
                           <a:cs typeface="Times New Roman" panose="02020603050405020304" pitchFamily="18" charset="0"/>
                         </a:rPr>
-                        <a:t>874.7</a:t>
+                        <a:t>544</a:t>
                       </a:r>
                     </a:p>
                   </a:txBody>
@@ -23984,7 +23984,7 @@
                           <a:ea typeface="Aptos" panose="020B0004020202020204" pitchFamily="34" charset="0"/>
                           <a:cs typeface="Times New Roman" panose="02020603050405020304" pitchFamily="18" charset="0"/>
                         </a:rPr>
-                        <a:t>363.4</a:t>
+                        <a:t>226</a:t>
                       </a:r>
                     </a:p>
                   </a:txBody>
@@ -24101,7 +24101,7 @@
           <a:p>
             <a:r>
               <a:rPr lang="en-US" b="1" dirty="0"/>
-              <a:t>875 km for R$7 extra</a:t>
+              <a:t>533 miles for R$ 7 (~ $1.40) extra </a:t>
             </a:r>
           </a:p>
           <a:p>

</xml_diff>

<commit_message>
Presentation and queries update
</commit_message>
<xml_diff>
--- a/presentation/Olist E-Commerce Analysis.pptx
+++ b/presentation/Olist E-Commerce Analysis.pptx
@@ -7,25 +7,28 @@
   <p:sldIdLst>
     <p:sldId id="256" r:id="rId2"/>
     <p:sldId id="257" r:id="rId3"/>
-    <p:sldId id="258" r:id="rId4"/>
-    <p:sldId id="259" r:id="rId5"/>
-    <p:sldId id="260" r:id="rId6"/>
-    <p:sldId id="261" r:id="rId7"/>
-    <p:sldId id="264" r:id="rId8"/>
-    <p:sldId id="262" r:id="rId9"/>
-    <p:sldId id="263" r:id="rId10"/>
-    <p:sldId id="265" r:id="rId11"/>
-    <p:sldId id="266" r:id="rId12"/>
-    <p:sldId id="267" r:id="rId13"/>
-    <p:sldId id="268" r:id="rId14"/>
-    <p:sldId id="269" r:id="rId15"/>
-    <p:sldId id="270" r:id="rId16"/>
-    <p:sldId id="271" r:id="rId17"/>
-    <p:sldId id="272" r:id="rId18"/>
-    <p:sldId id="275" r:id="rId19"/>
-    <p:sldId id="276" r:id="rId20"/>
-    <p:sldId id="273" r:id="rId21"/>
-    <p:sldId id="274" r:id="rId22"/>
+    <p:sldId id="279" r:id="rId4"/>
+    <p:sldId id="258" r:id="rId5"/>
+    <p:sldId id="259" r:id="rId6"/>
+    <p:sldId id="260" r:id="rId7"/>
+    <p:sldId id="277" r:id="rId8"/>
+    <p:sldId id="261" r:id="rId9"/>
+    <p:sldId id="278" r:id="rId10"/>
+    <p:sldId id="264" r:id="rId11"/>
+    <p:sldId id="262" r:id="rId12"/>
+    <p:sldId id="263" r:id="rId13"/>
+    <p:sldId id="265" r:id="rId14"/>
+    <p:sldId id="266" r:id="rId15"/>
+    <p:sldId id="267" r:id="rId16"/>
+    <p:sldId id="268" r:id="rId17"/>
+    <p:sldId id="269" r:id="rId18"/>
+    <p:sldId id="270" r:id="rId19"/>
+    <p:sldId id="271" r:id="rId20"/>
+    <p:sldId id="272" r:id="rId21"/>
+    <p:sldId id="275" r:id="rId22"/>
+    <p:sldId id="276" r:id="rId23"/>
+    <p:sldId id="273" r:id="rId24"/>
+    <p:sldId id="274" r:id="rId25"/>
   </p:sldIdLst>
   <p:sldSz cx="12192000" cy="6858000"/>
   <p:notesSz cx="6858000" cy="9144000"/>
@@ -925,6 +928,872 @@
 </pc:chgInfo>
 </file>
 
+<file path=ppt/charts/chart1.xml><?xml version="1.0" encoding="utf-8"?>
+<c:chartSpace xmlns:c="http://schemas.openxmlformats.org/drawingml/2006/chart" xmlns:a="http://schemas.openxmlformats.org/drawingml/2006/main" xmlns:r="http://schemas.openxmlformats.org/officeDocument/2006/relationships" xmlns:c16r2="http://schemas.microsoft.com/office/drawing/2015/06/chart">
+  <c:date1904 val="0"/>
+  <c:lang val="en-US"/>
+  <c:roundedCorners val="0"/>
+  <mc:AlternateContent xmlns:mc="http://schemas.openxmlformats.org/markup-compatibility/2006">
+    <mc:Choice xmlns:c14="http://schemas.microsoft.com/office/drawing/2007/8/2/chart" Requires="c14">
+      <c14:style val="102"/>
+    </mc:Choice>
+    <mc:Fallback>
+      <c:style val="2"/>
+    </mc:Fallback>
+  </mc:AlternateContent>
+  <c:chart>
+    <c:title>
+      <c:overlay val="0"/>
+      <c:spPr>
+        <a:noFill/>
+        <a:ln>
+          <a:noFill/>
+        </a:ln>
+        <a:effectLst/>
+      </c:spPr>
+      <c:txPr>
+        <a:bodyPr rot="0" spcFirstLastPara="1" vertOverflow="ellipsis" vert="horz" wrap="square" anchor="ctr" anchorCtr="1"/>
+        <a:lstStyle/>
+        <a:p>
+          <a:pPr>
+            <a:defRPr sz="2200" b="1" i="0" u="none" strike="noStrike" kern="1200" spc="0" baseline="0">
+              <a:solidFill>
+                <a:schemeClr val="tx1">
+                  <a:lumMod val="65000"/>
+                  <a:lumOff val="35000"/>
+                </a:schemeClr>
+              </a:solidFill>
+              <a:latin typeface="+mn-lt"/>
+              <a:ea typeface="+mn-ea"/>
+              <a:cs typeface="+mn-cs"/>
+            </a:defRPr>
+          </a:pPr>
+          <a:endParaRPr lang="en-US"/>
+        </a:p>
+      </c:txPr>
+    </c:title>
+    <c:autoTitleDeleted val="0"/>
+    <c:plotArea>
+      <c:layout/>
+      <c:barChart>
+        <c:barDir val="bar"/>
+        <c:grouping val="clustered"/>
+        <c:varyColors val="0"/>
+        <c:ser>
+          <c:idx val="0"/>
+          <c:order val="0"/>
+          <c:tx>
+            <c:strRef>
+              <c:f>Sheet1!$B$1</c:f>
+              <c:strCache>
+                <c:ptCount val="1"/>
+                <c:pt idx="0">
+                  <c:v>Revenue (R$ million)</c:v>
+                </c:pt>
+              </c:strCache>
+            </c:strRef>
+          </c:tx>
+          <c:spPr>
+            <a:solidFill>
+              <a:schemeClr val="accent1"/>
+            </a:solidFill>
+            <a:ln>
+              <a:noFill/>
+            </a:ln>
+            <a:effectLst/>
+          </c:spPr>
+          <c:invertIfNegative val="0"/>
+          <c:cat>
+            <c:strRef>
+              <c:f>Sheet1!$A$2:$A$11</c:f>
+              <c:strCache>
+                <c:ptCount val="10"/>
+                <c:pt idx="0">
+                  <c:v>garden_tools</c:v>
+                </c:pt>
+                <c:pt idx="1">
+                  <c:v>auto</c:v>
+                </c:pt>
+                <c:pt idx="2">
+                  <c:v>cool_stuff</c:v>
+                </c:pt>
+                <c:pt idx="3">
+                  <c:v>housewares</c:v>
+                </c:pt>
+                <c:pt idx="4">
+                  <c:v>furniture_decor</c:v>
+                </c:pt>
+                <c:pt idx="5">
+                  <c:v>computers_accessories</c:v>
+                </c:pt>
+                <c:pt idx="6">
+                  <c:v>sports_leisure</c:v>
+                </c:pt>
+                <c:pt idx="7">
+                  <c:v>bed_bath_table</c:v>
+                </c:pt>
+                <c:pt idx="8">
+                  <c:v>watches_gifts</c:v>
+                </c:pt>
+                <c:pt idx="9">
+                  <c:v>health_beauty</c:v>
+                </c:pt>
+              </c:strCache>
+            </c:strRef>
+          </c:cat>
+          <c:val>
+            <c:numRef>
+              <c:f>Sheet1!$B$2:$B$11</c:f>
+              <c:numCache>
+                <c:formatCode>#,##0.0</c:formatCode>
+                <c:ptCount val="10"/>
+                <c:pt idx="0">
+                  <c:v>0.58421920999999999</c:v>
+                </c:pt>
+                <c:pt idx="1">
+                  <c:v>0.68538431999999994</c:v>
+                </c:pt>
+                <c:pt idx="2">
+                  <c:v>0.71932995</c:v>
+                </c:pt>
+                <c:pt idx="3">
+                  <c:v>0.77839776999999999</c:v>
+                </c:pt>
+                <c:pt idx="4">
+                  <c:v>0.90251179000000004</c:v>
+                </c:pt>
+                <c:pt idx="5">
+                  <c:v>1.0592724</c:v>
+                </c:pt>
+                <c:pt idx="6">
+                  <c:v>1.1566564799999999</c:v>
+                </c:pt>
+                <c:pt idx="7">
+                  <c:v>1.2416817199999999</c:v>
+                </c:pt>
+                <c:pt idx="8">
+                  <c:v>1.3055416100000001</c:v>
+                </c:pt>
+                <c:pt idx="9">
+                  <c:v>1.4412480700000001</c:v>
+                </c:pt>
+              </c:numCache>
+            </c:numRef>
+          </c:val>
+          <c:extLst>
+            <c:ext xmlns:c16="http://schemas.microsoft.com/office/drawing/2014/chart" uri="{C3380CC4-5D6E-409C-BE32-E72D297353CC}">
+              <c16:uniqueId val="{00000000-87CC-4C8F-9E73-961FD4132C93}"/>
+            </c:ext>
+          </c:extLst>
+        </c:ser>
+        <c:dLbls>
+          <c:showLegendKey val="0"/>
+          <c:showVal val="0"/>
+          <c:showCatName val="0"/>
+          <c:showSerName val="0"/>
+          <c:showPercent val="0"/>
+          <c:showBubbleSize val="0"/>
+        </c:dLbls>
+        <c:gapWidth val="219"/>
+        <c:axId val="1378809056"/>
+        <c:axId val="1378799936"/>
+      </c:barChart>
+      <c:catAx>
+        <c:axId val="1378809056"/>
+        <c:scaling>
+          <c:orientation val="minMax"/>
+        </c:scaling>
+        <c:delete val="0"/>
+        <c:axPos val="l"/>
+        <c:numFmt formatCode="General" sourceLinked="1"/>
+        <c:majorTickMark val="none"/>
+        <c:minorTickMark val="none"/>
+        <c:tickLblPos val="nextTo"/>
+        <c:spPr>
+          <a:noFill/>
+          <a:ln w="9525" cap="flat" cmpd="sng" algn="ctr">
+            <a:solidFill>
+              <a:schemeClr val="tx1">
+                <a:lumMod val="15000"/>
+                <a:lumOff val="85000"/>
+              </a:schemeClr>
+            </a:solidFill>
+            <a:round/>
+          </a:ln>
+          <a:effectLst/>
+        </c:spPr>
+        <c:txPr>
+          <a:bodyPr rot="-60000000" spcFirstLastPara="1" vertOverflow="ellipsis" vert="horz" wrap="square" anchor="ctr" anchorCtr="1"/>
+          <a:lstStyle/>
+          <a:p>
+            <a:pPr>
+              <a:defRPr sz="2200" b="0" i="0" u="none" strike="noStrike" kern="1200" baseline="0">
+                <a:ln>
+                  <a:noFill/>
+                </a:ln>
+                <a:solidFill>
+                  <a:schemeClr val="tx1">
+                    <a:lumMod val="65000"/>
+                    <a:lumOff val="35000"/>
+                  </a:schemeClr>
+                </a:solidFill>
+                <a:latin typeface="+mn-lt"/>
+                <a:ea typeface="+mn-ea"/>
+                <a:cs typeface="+mn-cs"/>
+              </a:defRPr>
+            </a:pPr>
+            <a:endParaRPr lang="en-US"/>
+          </a:p>
+        </c:txPr>
+        <c:crossAx val="1378799936"/>
+        <c:crosses val="autoZero"/>
+        <c:auto val="1"/>
+        <c:lblAlgn val="ctr"/>
+        <c:lblOffset val="100"/>
+        <c:noMultiLvlLbl val="0"/>
+      </c:catAx>
+      <c:valAx>
+        <c:axId val="1378799936"/>
+        <c:scaling>
+          <c:orientation val="minMax"/>
+          <c:max val="1.5"/>
+        </c:scaling>
+        <c:delete val="0"/>
+        <c:axPos val="b"/>
+        <c:majorGridlines>
+          <c:spPr>
+            <a:ln w="9525" cap="flat" cmpd="sng" algn="ctr">
+              <a:solidFill>
+                <a:schemeClr val="tx1">
+                  <a:lumMod val="15000"/>
+                  <a:lumOff val="85000"/>
+                </a:schemeClr>
+              </a:solidFill>
+              <a:round/>
+            </a:ln>
+            <a:effectLst/>
+          </c:spPr>
+        </c:majorGridlines>
+        <c:numFmt formatCode="#,##0.0" sourceLinked="1"/>
+        <c:majorTickMark val="none"/>
+        <c:minorTickMark val="none"/>
+        <c:tickLblPos val="nextTo"/>
+        <c:spPr>
+          <a:noFill/>
+          <a:ln>
+            <a:noFill/>
+          </a:ln>
+          <a:effectLst/>
+        </c:spPr>
+        <c:txPr>
+          <a:bodyPr rot="-60000000" spcFirstLastPara="1" vertOverflow="ellipsis" vert="horz" wrap="square" anchor="ctr" anchorCtr="1"/>
+          <a:lstStyle/>
+          <a:p>
+            <a:pPr>
+              <a:defRPr sz="2200" b="0" i="0" u="none" strike="noStrike" kern="1200" baseline="0">
+                <a:solidFill>
+                  <a:schemeClr val="tx1">
+                    <a:lumMod val="65000"/>
+                    <a:lumOff val="35000"/>
+                  </a:schemeClr>
+                </a:solidFill>
+                <a:latin typeface="+mn-lt"/>
+                <a:ea typeface="+mn-ea"/>
+                <a:cs typeface="+mn-cs"/>
+              </a:defRPr>
+            </a:pPr>
+            <a:endParaRPr lang="en-US"/>
+          </a:p>
+        </c:txPr>
+        <c:crossAx val="1378809056"/>
+        <c:crosses val="autoZero"/>
+        <c:crossBetween val="between"/>
+      </c:valAx>
+      <c:spPr>
+        <a:noFill/>
+        <a:ln>
+          <a:noFill/>
+        </a:ln>
+        <a:effectLst/>
+      </c:spPr>
+    </c:plotArea>
+    <c:plotVisOnly val="1"/>
+    <c:dispBlanksAs val="gap"/>
+    <c:showDLblsOverMax val="0"/>
+    <c:extLst>
+      <c:ext xmlns:c16r3="http://schemas.microsoft.com/office/drawing/2017/03/chart" uri="{56B9EC1D-385E-4148-901F-78D8002777C0}">
+        <c16r3:dataDisplayOptions16>
+          <c16r3:dispNaAsBlank val="1"/>
+        </c16r3:dataDisplayOptions16>
+      </c:ext>
+    </c:extLst>
+  </c:chart>
+  <c:spPr>
+    <a:noFill/>
+    <a:ln>
+      <a:noFill/>
+    </a:ln>
+    <a:effectLst/>
+  </c:spPr>
+  <c:txPr>
+    <a:bodyPr/>
+    <a:lstStyle/>
+    <a:p>
+      <a:pPr>
+        <a:defRPr/>
+      </a:pPr>
+      <a:endParaRPr lang="en-US"/>
+    </a:p>
+  </c:txPr>
+  <c:externalData r:id="rId3">
+    <c:autoUpdate val="0"/>
+  </c:externalData>
+</c:chartSpace>
+</file>
+
+<file path=ppt/charts/colors1.xml><?xml version="1.0" encoding="utf-8"?>
+<cs:colorStyle xmlns:cs="http://schemas.microsoft.com/office/drawing/2012/chartStyle" xmlns:a="http://schemas.openxmlformats.org/drawingml/2006/main" meth="cycle" id="10">
+  <a:schemeClr val="accent1"/>
+  <a:schemeClr val="accent2"/>
+  <a:schemeClr val="accent3"/>
+  <a:schemeClr val="accent4"/>
+  <a:schemeClr val="accent5"/>
+  <a:schemeClr val="accent6"/>
+  <cs:variation/>
+  <cs:variation>
+    <a:lumMod val="60000"/>
+  </cs:variation>
+  <cs:variation>
+    <a:lumMod val="80000"/>
+    <a:lumOff val="20000"/>
+  </cs:variation>
+  <cs:variation>
+    <a:lumMod val="80000"/>
+  </cs:variation>
+  <cs:variation>
+    <a:lumMod val="60000"/>
+    <a:lumOff val="40000"/>
+  </cs:variation>
+  <cs:variation>
+    <a:lumMod val="50000"/>
+  </cs:variation>
+  <cs:variation>
+    <a:lumMod val="70000"/>
+    <a:lumOff val="30000"/>
+  </cs:variation>
+  <cs:variation>
+    <a:lumMod val="70000"/>
+  </cs:variation>
+  <cs:variation>
+    <a:lumMod val="50000"/>
+    <a:lumOff val="50000"/>
+  </cs:variation>
+</cs:colorStyle>
+</file>
+
+<file path=ppt/charts/style1.xml><?xml version="1.0" encoding="utf-8"?>
+<cs:chartStyle xmlns:cs="http://schemas.microsoft.com/office/drawing/2012/chartStyle" xmlns:a="http://schemas.openxmlformats.org/drawingml/2006/main" id="201">
+  <cs:axisTitle>
+    <cs:lnRef idx="0"/>
+    <cs:fillRef idx="0"/>
+    <cs:effectRef idx="0"/>
+    <cs:fontRef idx="minor">
+      <a:schemeClr val="tx1">
+        <a:lumMod val="65000"/>
+        <a:lumOff val="35000"/>
+      </a:schemeClr>
+    </cs:fontRef>
+    <cs:defRPr sz="1330" kern="1200"/>
+  </cs:axisTitle>
+  <cs:categoryAxis>
+    <cs:lnRef idx="0"/>
+    <cs:fillRef idx="0"/>
+    <cs:effectRef idx="0"/>
+    <cs:fontRef idx="minor">
+      <a:schemeClr val="tx1">
+        <a:lumMod val="65000"/>
+        <a:lumOff val="35000"/>
+      </a:schemeClr>
+    </cs:fontRef>
+    <cs:spPr>
+      <a:ln w="9525" cap="flat" cmpd="sng" algn="ctr">
+        <a:solidFill>
+          <a:schemeClr val="tx1">
+            <a:lumMod val="15000"/>
+            <a:lumOff val="85000"/>
+          </a:schemeClr>
+        </a:solidFill>
+        <a:round/>
+      </a:ln>
+    </cs:spPr>
+    <cs:defRPr sz="1197" kern="1200"/>
+  </cs:categoryAxis>
+  <cs:chartArea mods="allowNoFillOverride allowNoLineOverride">
+    <cs:lnRef idx="0"/>
+    <cs:fillRef idx="0"/>
+    <cs:effectRef idx="0"/>
+    <cs:fontRef idx="minor">
+      <a:schemeClr val="tx1"/>
+    </cs:fontRef>
+    <cs:spPr>
+      <a:solidFill>
+        <a:schemeClr val="bg1"/>
+      </a:solidFill>
+      <a:ln w="9525" cap="flat" cmpd="sng" algn="ctr">
+        <a:solidFill>
+          <a:schemeClr val="tx1">
+            <a:lumMod val="15000"/>
+            <a:lumOff val="85000"/>
+          </a:schemeClr>
+        </a:solidFill>
+        <a:round/>
+      </a:ln>
+    </cs:spPr>
+    <cs:defRPr sz="1330" kern="1200"/>
+  </cs:chartArea>
+  <cs:dataLabel>
+    <cs:lnRef idx="0"/>
+    <cs:fillRef idx="0"/>
+    <cs:effectRef idx="0"/>
+    <cs:fontRef idx="minor">
+      <a:schemeClr val="tx1">
+        <a:lumMod val="75000"/>
+        <a:lumOff val="25000"/>
+      </a:schemeClr>
+    </cs:fontRef>
+    <cs:defRPr sz="1197" kern="1200"/>
+  </cs:dataLabel>
+  <cs:dataLabelCallout>
+    <cs:lnRef idx="0"/>
+    <cs:fillRef idx="0"/>
+    <cs:effectRef idx="0"/>
+    <cs:fontRef idx="minor">
+      <a:schemeClr val="dk1">
+        <a:lumMod val="65000"/>
+        <a:lumOff val="35000"/>
+      </a:schemeClr>
+    </cs:fontRef>
+    <cs:spPr>
+      <a:solidFill>
+        <a:schemeClr val="lt1"/>
+      </a:solidFill>
+      <a:ln>
+        <a:solidFill>
+          <a:schemeClr val="dk1">
+            <a:lumMod val="25000"/>
+            <a:lumOff val="75000"/>
+          </a:schemeClr>
+        </a:solidFill>
+      </a:ln>
+    </cs:spPr>
+    <cs:defRPr sz="1197" kern="1200"/>
+    <cs:bodyPr rot="0" spcFirstLastPara="1" vertOverflow="clip" horzOverflow="clip" vert="horz" wrap="square" lIns="36576" tIns="18288" rIns="36576" bIns="18288" anchor="ctr" anchorCtr="1">
+      <a:spAutoFit/>
+    </cs:bodyPr>
+  </cs:dataLabelCallout>
+  <cs:dataPoint>
+    <cs:lnRef idx="0"/>
+    <cs:fillRef idx="1">
+      <cs:styleClr val="auto"/>
+    </cs:fillRef>
+    <cs:effectRef idx="0"/>
+    <cs:fontRef idx="minor">
+      <a:schemeClr val="tx1"/>
+    </cs:fontRef>
+  </cs:dataPoint>
+  <cs:dataPoint3D>
+    <cs:lnRef idx="0"/>
+    <cs:fillRef idx="1">
+      <cs:styleClr val="auto"/>
+    </cs:fillRef>
+    <cs:effectRef idx="0"/>
+    <cs:fontRef idx="minor">
+      <a:schemeClr val="tx1"/>
+    </cs:fontRef>
+  </cs:dataPoint3D>
+  <cs:dataPointLine>
+    <cs:lnRef idx="0">
+      <cs:styleClr val="auto"/>
+    </cs:lnRef>
+    <cs:fillRef idx="1"/>
+    <cs:effectRef idx="0"/>
+    <cs:fontRef idx="minor">
+      <a:schemeClr val="tx1"/>
+    </cs:fontRef>
+    <cs:spPr>
+      <a:ln w="28575" cap="rnd">
+        <a:solidFill>
+          <a:schemeClr val="phClr"/>
+        </a:solidFill>
+        <a:round/>
+      </a:ln>
+    </cs:spPr>
+  </cs:dataPointLine>
+  <cs:dataPointMarker>
+    <cs:lnRef idx="0">
+      <cs:styleClr val="auto"/>
+    </cs:lnRef>
+    <cs:fillRef idx="1">
+      <cs:styleClr val="auto"/>
+    </cs:fillRef>
+    <cs:effectRef idx="0"/>
+    <cs:fontRef idx="minor">
+      <a:schemeClr val="tx1"/>
+    </cs:fontRef>
+    <cs:spPr>
+      <a:ln w="9525">
+        <a:solidFill>
+          <a:schemeClr val="phClr"/>
+        </a:solidFill>
+      </a:ln>
+    </cs:spPr>
+  </cs:dataPointMarker>
+  <cs:dataPointMarkerLayout symbol="circle" size="5"/>
+  <cs:dataPointWireframe>
+    <cs:lnRef idx="0">
+      <cs:styleClr val="auto"/>
+    </cs:lnRef>
+    <cs:fillRef idx="1"/>
+    <cs:effectRef idx="0"/>
+    <cs:fontRef idx="minor">
+      <a:schemeClr val="tx1"/>
+    </cs:fontRef>
+    <cs:spPr>
+      <a:ln w="9525" cap="rnd">
+        <a:solidFill>
+          <a:schemeClr val="phClr"/>
+        </a:solidFill>
+        <a:round/>
+      </a:ln>
+    </cs:spPr>
+  </cs:dataPointWireframe>
+  <cs:dataTable>
+    <cs:lnRef idx="0"/>
+    <cs:fillRef idx="0"/>
+    <cs:effectRef idx="0"/>
+    <cs:fontRef idx="minor">
+      <a:schemeClr val="tx1">
+        <a:lumMod val="65000"/>
+        <a:lumOff val="35000"/>
+      </a:schemeClr>
+    </cs:fontRef>
+    <cs:spPr>
+      <a:noFill/>
+      <a:ln w="9525" cap="flat" cmpd="sng" algn="ctr">
+        <a:solidFill>
+          <a:schemeClr val="tx1">
+            <a:lumMod val="15000"/>
+            <a:lumOff val="85000"/>
+          </a:schemeClr>
+        </a:solidFill>
+        <a:round/>
+      </a:ln>
+    </cs:spPr>
+    <cs:defRPr sz="1197" kern="1200"/>
+  </cs:dataTable>
+  <cs:downBar>
+    <cs:lnRef idx="0"/>
+    <cs:fillRef idx="0"/>
+    <cs:effectRef idx="0"/>
+    <cs:fontRef idx="minor">
+      <a:schemeClr val="dk1"/>
+    </cs:fontRef>
+    <cs:spPr>
+      <a:solidFill>
+        <a:schemeClr val="dk1">
+          <a:lumMod val="65000"/>
+          <a:lumOff val="35000"/>
+        </a:schemeClr>
+      </a:solidFill>
+      <a:ln w="9525">
+        <a:solidFill>
+          <a:schemeClr val="tx1">
+            <a:lumMod val="65000"/>
+            <a:lumOff val="35000"/>
+          </a:schemeClr>
+        </a:solidFill>
+      </a:ln>
+    </cs:spPr>
+  </cs:downBar>
+  <cs:dropLine>
+    <cs:lnRef idx="0"/>
+    <cs:fillRef idx="0"/>
+    <cs:effectRef idx="0"/>
+    <cs:fontRef idx="minor">
+      <a:schemeClr val="tx1"/>
+    </cs:fontRef>
+    <cs:spPr>
+      <a:ln w="9525" cap="flat" cmpd="sng" algn="ctr">
+        <a:solidFill>
+          <a:schemeClr val="tx1">
+            <a:lumMod val="35000"/>
+            <a:lumOff val="65000"/>
+          </a:schemeClr>
+        </a:solidFill>
+        <a:round/>
+      </a:ln>
+    </cs:spPr>
+  </cs:dropLine>
+  <cs:errorBar>
+    <cs:lnRef idx="0"/>
+    <cs:fillRef idx="0"/>
+    <cs:effectRef idx="0"/>
+    <cs:fontRef idx="minor">
+      <a:schemeClr val="tx1"/>
+    </cs:fontRef>
+    <cs:spPr>
+      <a:ln w="9525" cap="flat" cmpd="sng" algn="ctr">
+        <a:solidFill>
+          <a:schemeClr val="tx1">
+            <a:lumMod val="65000"/>
+            <a:lumOff val="35000"/>
+          </a:schemeClr>
+        </a:solidFill>
+        <a:round/>
+      </a:ln>
+    </cs:spPr>
+  </cs:errorBar>
+  <cs:floor>
+    <cs:lnRef idx="0"/>
+    <cs:fillRef idx="0"/>
+    <cs:effectRef idx="0"/>
+    <cs:fontRef idx="minor">
+      <a:schemeClr val="tx1"/>
+    </cs:fontRef>
+    <cs:spPr>
+      <a:noFill/>
+      <a:ln>
+        <a:noFill/>
+      </a:ln>
+    </cs:spPr>
+  </cs:floor>
+  <cs:gridlineMajor>
+    <cs:lnRef idx="0"/>
+    <cs:fillRef idx="0"/>
+    <cs:effectRef idx="0"/>
+    <cs:fontRef idx="minor">
+      <a:schemeClr val="tx1"/>
+    </cs:fontRef>
+    <cs:spPr>
+      <a:ln w="9525" cap="flat" cmpd="sng" algn="ctr">
+        <a:solidFill>
+          <a:schemeClr val="tx1">
+            <a:lumMod val="15000"/>
+            <a:lumOff val="85000"/>
+          </a:schemeClr>
+        </a:solidFill>
+        <a:round/>
+      </a:ln>
+    </cs:spPr>
+  </cs:gridlineMajor>
+  <cs:gridlineMinor>
+    <cs:lnRef idx="0"/>
+    <cs:fillRef idx="0"/>
+    <cs:effectRef idx="0"/>
+    <cs:fontRef idx="minor">
+      <a:schemeClr val="tx1"/>
+    </cs:fontRef>
+    <cs:spPr>
+      <a:ln w="9525" cap="flat" cmpd="sng" algn="ctr">
+        <a:solidFill>
+          <a:schemeClr val="tx1">
+            <a:lumMod val="5000"/>
+            <a:lumOff val="95000"/>
+          </a:schemeClr>
+        </a:solidFill>
+        <a:round/>
+      </a:ln>
+    </cs:spPr>
+  </cs:gridlineMinor>
+  <cs:hiLoLine>
+    <cs:lnRef idx="0"/>
+    <cs:fillRef idx="0"/>
+    <cs:effectRef idx="0"/>
+    <cs:fontRef idx="minor">
+      <a:schemeClr val="tx1"/>
+    </cs:fontRef>
+    <cs:spPr>
+      <a:ln w="9525" cap="flat" cmpd="sng" algn="ctr">
+        <a:solidFill>
+          <a:schemeClr val="tx1">
+            <a:lumMod val="75000"/>
+            <a:lumOff val="25000"/>
+          </a:schemeClr>
+        </a:solidFill>
+        <a:round/>
+      </a:ln>
+    </cs:spPr>
+  </cs:hiLoLine>
+  <cs:leaderLine>
+    <cs:lnRef idx="0"/>
+    <cs:fillRef idx="0"/>
+    <cs:effectRef idx="0"/>
+    <cs:fontRef idx="minor">
+      <a:schemeClr val="tx1"/>
+    </cs:fontRef>
+    <cs:spPr>
+      <a:ln w="9525" cap="flat" cmpd="sng" algn="ctr">
+        <a:solidFill>
+          <a:schemeClr val="tx1">
+            <a:lumMod val="35000"/>
+            <a:lumOff val="65000"/>
+          </a:schemeClr>
+        </a:solidFill>
+        <a:round/>
+      </a:ln>
+    </cs:spPr>
+  </cs:leaderLine>
+  <cs:legend>
+    <cs:lnRef idx="0"/>
+    <cs:fillRef idx="0"/>
+    <cs:effectRef idx="0"/>
+    <cs:fontRef idx="minor">
+      <a:schemeClr val="tx1">
+        <a:lumMod val="65000"/>
+        <a:lumOff val="35000"/>
+      </a:schemeClr>
+    </cs:fontRef>
+    <cs:defRPr sz="1197" kern="1200"/>
+  </cs:legend>
+  <cs:plotArea mods="allowNoFillOverride allowNoLineOverride">
+    <cs:lnRef idx="0"/>
+    <cs:fillRef idx="0"/>
+    <cs:effectRef idx="0"/>
+    <cs:fontRef idx="minor">
+      <a:schemeClr val="tx1"/>
+    </cs:fontRef>
+  </cs:plotArea>
+  <cs:plotArea3D mods="allowNoFillOverride allowNoLineOverride">
+    <cs:lnRef idx="0"/>
+    <cs:fillRef idx="0"/>
+    <cs:effectRef idx="0"/>
+    <cs:fontRef idx="minor">
+      <a:schemeClr val="tx1"/>
+    </cs:fontRef>
+  </cs:plotArea3D>
+  <cs:seriesAxis>
+    <cs:lnRef idx="0"/>
+    <cs:fillRef idx="0"/>
+    <cs:effectRef idx="0"/>
+    <cs:fontRef idx="minor">
+      <a:schemeClr val="tx1">
+        <a:lumMod val="65000"/>
+        <a:lumOff val="35000"/>
+      </a:schemeClr>
+    </cs:fontRef>
+    <cs:defRPr sz="1197" kern="1200"/>
+  </cs:seriesAxis>
+  <cs:seriesLine>
+    <cs:lnRef idx="0"/>
+    <cs:fillRef idx="0"/>
+    <cs:effectRef idx="0"/>
+    <cs:fontRef idx="minor">
+      <a:schemeClr val="tx1"/>
+    </cs:fontRef>
+    <cs:spPr>
+      <a:ln w="9525" cap="flat" cmpd="sng" algn="ctr">
+        <a:solidFill>
+          <a:schemeClr val="tx1">
+            <a:lumMod val="35000"/>
+            <a:lumOff val="65000"/>
+          </a:schemeClr>
+        </a:solidFill>
+        <a:round/>
+      </a:ln>
+    </cs:spPr>
+  </cs:seriesLine>
+  <cs:title>
+    <cs:lnRef idx="0"/>
+    <cs:fillRef idx="0"/>
+    <cs:effectRef idx="0"/>
+    <cs:fontRef idx="minor">
+      <a:schemeClr val="tx1">
+        <a:lumMod val="65000"/>
+        <a:lumOff val="35000"/>
+      </a:schemeClr>
+    </cs:fontRef>
+    <cs:defRPr sz="1862" b="0" kern="1200" spc="0" baseline="0"/>
+  </cs:title>
+  <cs:trendline>
+    <cs:lnRef idx="0">
+      <cs:styleClr val="auto"/>
+    </cs:lnRef>
+    <cs:fillRef idx="0"/>
+    <cs:effectRef idx="0"/>
+    <cs:fontRef idx="minor">
+      <a:schemeClr val="tx1"/>
+    </cs:fontRef>
+    <cs:spPr>
+      <a:ln w="19050" cap="rnd">
+        <a:solidFill>
+          <a:schemeClr val="phClr"/>
+        </a:solidFill>
+        <a:prstDash val="sysDot"/>
+      </a:ln>
+    </cs:spPr>
+  </cs:trendline>
+  <cs:trendlineLabel>
+    <cs:lnRef idx="0"/>
+    <cs:fillRef idx="0"/>
+    <cs:effectRef idx="0"/>
+    <cs:fontRef idx="minor">
+      <a:schemeClr val="tx1">
+        <a:lumMod val="65000"/>
+        <a:lumOff val="35000"/>
+      </a:schemeClr>
+    </cs:fontRef>
+    <cs:defRPr sz="1197" kern="1200"/>
+  </cs:trendlineLabel>
+  <cs:upBar>
+    <cs:lnRef idx="0"/>
+    <cs:fillRef idx="0"/>
+    <cs:effectRef idx="0"/>
+    <cs:fontRef idx="minor">
+      <a:schemeClr val="dk1"/>
+    </cs:fontRef>
+    <cs:spPr>
+      <a:solidFill>
+        <a:schemeClr val="lt1"/>
+      </a:solidFill>
+      <a:ln w="9525">
+        <a:solidFill>
+          <a:schemeClr val="tx1">
+            <a:lumMod val="15000"/>
+            <a:lumOff val="85000"/>
+          </a:schemeClr>
+        </a:solidFill>
+      </a:ln>
+    </cs:spPr>
+  </cs:upBar>
+  <cs:valueAxis>
+    <cs:lnRef idx="0"/>
+    <cs:fillRef idx="0"/>
+    <cs:effectRef idx="0"/>
+    <cs:fontRef idx="minor">
+      <a:schemeClr val="tx1">
+        <a:lumMod val="65000"/>
+        <a:lumOff val="35000"/>
+      </a:schemeClr>
+    </cs:fontRef>
+    <cs:defRPr sz="1197" kern="1200"/>
+  </cs:valueAxis>
+  <cs:wall>
+    <cs:lnRef idx="0"/>
+    <cs:fillRef idx="0"/>
+    <cs:effectRef idx="0"/>
+    <cs:fontRef idx="minor">
+      <a:schemeClr val="tx1"/>
+    </cs:fontRef>
+    <cs:spPr>
+      <a:noFill/>
+      <a:ln>
+        <a:noFill/>
+      </a:ln>
+    </cs:spPr>
+  </cs:wall>
+</cs:chartStyle>
+</file>
+
 <file path=ppt/slideLayouts/slideLayout1.xml><?xml version="1.0" encoding="utf-8"?>
 <p:sldLayout xmlns:a="http://schemas.openxmlformats.org/drawingml/2006/main" xmlns:r="http://schemas.openxmlformats.org/officeDocument/2006/relationships" xmlns:p="http://schemas.openxmlformats.org/presentationml/2006/main" showMasterSp="0" type="title" preserve="1">
   <p:cSld name="Title Slide">
@@ -9732,7 +10601,7 @@
           <a:p>
             <a:fld id="{B2374077-9B34-4FA8-8422-634E903F67E1}" type="datetimeFigureOut">
               <a:rPr lang="en-US" smtClean="0"/>
-              <a:t>4/15/2026</a:t>
+              <a:t>4/19/2026</a:t>
             </a:fld>
             <a:endParaRPr lang="en-US"/>
           </a:p>
@@ -9939,7 +10808,7 @@
           <a:p>
             <a:fld id="{B2374077-9B34-4FA8-8422-634E903F67E1}" type="datetimeFigureOut">
               <a:rPr lang="en-US" smtClean="0"/>
-              <a:t>4/15/2026</a:t>
+              <a:t>4/19/2026</a:t>
             </a:fld>
             <a:endParaRPr lang="en-US"/>
           </a:p>
@@ -10119,7 +10988,7 @@
           <a:p>
             <a:fld id="{B2374077-9B34-4FA8-8422-634E903F67E1}" type="datetimeFigureOut">
               <a:rPr lang="en-US" smtClean="0"/>
-              <a:t>4/15/2026</a:t>
+              <a:t>4/19/2026</a:t>
             </a:fld>
             <a:endParaRPr lang="en-US"/>
           </a:p>
@@ -10324,7 +11193,7 @@
           <a:p>
             <a:fld id="{B2374077-9B34-4FA8-8422-634E903F67E1}" type="datetimeFigureOut">
               <a:rPr lang="en-US" smtClean="0"/>
-              <a:t>4/15/2026</a:t>
+              <a:t>4/19/2026</a:t>
             </a:fld>
             <a:endParaRPr lang="en-US"/>
           </a:p>
@@ -19236,7 +20105,7 @@
           <a:p>
             <a:fld id="{B2374077-9B34-4FA8-8422-634E903F67E1}" type="datetimeFigureOut">
               <a:rPr lang="en-US" smtClean="0"/>
-              <a:t>4/15/2026</a:t>
+              <a:t>4/19/2026</a:t>
             </a:fld>
             <a:endParaRPr lang="en-US"/>
           </a:p>
@@ -19510,7 +20379,7 @@
           <a:p>
             <a:fld id="{B2374077-9B34-4FA8-8422-634E903F67E1}" type="datetimeFigureOut">
               <a:rPr lang="en-US" smtClean="0"/>
-              <a:t>4/15/2026</a:t>
+              <a:t>4/19/2026</a:t>
             </a:fld>
             <a:endParaRPr lang="en-US"/>
           </a:p>
@@ -19908,7 +20777,7 @@
           <a:p>
             <a:fld id="{B2374077-9B34-4FA8-8422-634E903F67E1}" type="datetimeFigureOut">
               <a:rPr lang="en-US" smtClean="0"/>
-              <a:t>4/15/2026</a:t>
+              <a:t>4/19/2026</a:t>
             </a:fld>
             <a:endParaRPr lang="en-US"/>
           </a:p>
@@ -20026,7 +20895,7 @@
           <a:p>
             <a:fld id="{B2374077-9B34-4FA8-8422-634E903F67E1}" type="datetimeFigureOut">
               <a:rPr lang="en-US" smtClean="0"/>
-              <a:t>4/15/2026</a:t>
+              <a:t>4/19/2026</a:t>
             </a:fld>
             <a:endParaRPr lang="en-US"/>
           </a:p>
@@ -20121,7 +20990,7 @@
           <a:p>
             <a:fld id="{B2374077-9B34-4FA8-8422-634E903F67E1}" type="datetimeFigureOut">
               <a:rPr lang="en-US" smtClean="0"/>
-              <a:t>4/15/2026</a:t>
+              <a:t>4/19/2026</a:t>
             </a:fld>
             <a:endParaRPr lang="en-US"/>
           </a:p>
@@ -20411,7 +21280,7 @@
           <a:p>
             <a:fld id="{B2374077-9B34-4FA8-8422-634E903F67E1}" type="datetimeFigureOut">
               <a:rPr lang="en-US" smtClean="0"/>
-              <a:t>4/15/2026</a:t>
+              <a:t>4/19/2026</a:t>
             </a:fld>
             <a:endParaRPr lang="en-US"/>
           </a:p>
@@ -20691,7 +21560,7 @@
           <a:p>
             <a:fld id="{B2374077-9B34-4FA8-8422-634E903F67E1}" type="datetimeFigureOut">
               <a:rPr lang="en-US" smtClean="0"/>
-              <a:t>4/15/2026</a:t>
+              <a:t>4/19/2026</a:t>
             </a:fld>
             <a:endParaRPr lang="en-US"/>
           </a:p>
@@ -20941,7 +21810,7 @@
           <a:p>
             <a:fld id="{B2374077-9B34-4FA8-8422-634E903F67E1}" type="datetimeFigureOut">
               <a:rPr lang="en-US" smtClean="0"/>
-              <a:t>4/15/2026</a:t>
+              <a:t>4/19/2026</a:t>
             </a:fld>
             <a:endParaRPr lang="en-US"/>
           </a:p>
@@ -21529,6 +22398,432 @@
   <p:cSld>
     <p:spTree>
       <p:nvGrpSpPr>
+        <p:cNvPr id="1" name=""/>
+        <p:cNvGrpSpPr/>
+        <p:nvPr/>
+      </p:nvGrpSpPr>
+      <p:grpSpPr>
+        <a:xfrm>
+          <a:off x="0" y="0"/>
+          <a:ext cx="0" cy="0"/>
+          <a:chOff x="0" y="0"/>
+          <a:chExt cx="0" cy="0"/>
+        </a:xfrm>
+      </p:grpSpPr>
+      <p:sp>
+        <p:nvSpPr>
+          <p:cNvPr id="7" name="Title 6">
+            <a:extLst>
+              <a:ext uri="{FF2B5EF4-FFF2-40B4-BE49-F238E27FC236}">
+                <a16:creationId xmlns:a16="http://schemas.microsoft.com/office/drawing/2014/main" id="{5BD0FE1D-EE1D-CBA0-440A-FC5AF9D86BAB}"/>
+              </a:ext>
+            </a:extLst>
+          </p:cNvPr>
+          <p:cNvSpPr>
+            <a:spLocks noGrp="1"/>
+          </p:cNvSpPr>
+          <p:nvPr>
+            <p:ph type="title"/>
+          </p:nvPr>
+        </p:nvSpPr>
+        <p:spPr/>
+        <p:txBody>
+          <a:bodyPr/>
+          <a:lstStyle/>
+          <a:p>
+            <a:r>
+              <a:rPr lang="en-US" dirty="0"/>
+              <a:t>Customer &amp; Delivery Behavior</a:t>
+            </a:r>
+          </a:p>
+        </p:txBody>
+      </p:sp>
+      <p:sp>
+        <p:nvSpPr>
+          <p:cNvPr id="8" name="Text Placeholder 7">
+            <a:extLst>
+              <a:ext uri="{FF2B5EF4-FFF2-40B4-BE49-F238E27FC236}">
+                <a16:creationId xmlns:a16="http://schemas.microsoft.com/office/drawing/2014/main" id="{B732DF04-1DE9-5BF9-6277-EF7309B44354}"/>
+              </a:ext>
+            </a:extLst>
+          </p:cNvPr>
+          <p:cNvSpPr>
+            <a:spLocks noGrp="1"/>
+          </p:cNvSpPr>
+          <p:nvPr>
+            <p:ph type="body" idx="1"/>
+          </p:nvPr>
+        </p:nvSpPr>
+        <p:spPr/>
+        <p:txBody>
+          <a:bodyPr/>
+          <a:lstStyle/>
+          <a:p>
+            <a:r>
+              <a:rPr lang="en-US" dirty="0"/>
+              <a:t>Michael Amaya | Q5–Q8</a:t>
+            </a:r>
+          </a:p>
+        </p:txBody>
+      </p:sp>
+    </p:spTree>
+    <p:extLst>
+      <p:ext uri="{BB962C8B-B14F-4D97-AF65-F5344CB8AC3E}">
+        <p14:creationId xmlns:p14="http://schemas.microsoft.com/office/powerpoint/2010/main" val="2306582258"/>
+      </p:ext>
+    </p:extLst>
+  </p:cSld>
+  <p:clrMapOvr>
+    <a:masterClrMapping/>
+  </p:clrMapOvr>
+</p:sld>
+</file>
+
+<file path=ppt/slides/slide11.xml><?xml version="1.0" encoding="utf-8"?>
+<p:sld xmlns:a="http://schemas.openxmlformats.org/drawingml/2006/main" xmlns:r="http://schemas.openxmlformats.org/officeDocument/2006/relationships" xmlns:p="http://schemas.openxmlformats.org/presentationml/2006/main">
+  <p:cSld>
+    <p:spTree>
+      <p:nvGrpSpPr>
+        <p:cNvPr id="1" name=""/>
+        <p:cNvGrpSpPr/>
+        <p:nvPr/>
+      </p:nvGrpSpPr>
+      <p:grpSpPr>
+        <a:xfrm>
+          <a:off x="0" y="0"/>
+          <a:ext cx="0" cy="0"/>
+          <a:chOff x="0" y="0"/>
+          <a:chExt cx="0" cy="0"/>
+        </a:xfrm>
+      </p:grpSpPr>
+      <p:sp>
+        <p:nvSpPr>
+          <p:cNvPr id="2" name="Title 1">
+            <a:extLst>
+              <a:ext uri="{FF2B5EF4-FFF2-40B4-BE49-F238E27FC236}">
+                <a16:creationId xmlns:a16="http://schemas.microsoft.com/office/drawing/2014/main" id="{A7D68A88-CD02-E230-F679-81946D1CFA58}"/>
+              </a:ext>
+            </a:extLst>
+          </p:cNvPr>
+          <p:cNvSpPr>
+            <a:spLocks noGrp="1"/>
+          </p:cNvSpPr>
+          <p:nvPr>
+            <p:ph type="title"/>
+          </p:nvPr>
+        </p:nvSpPr>
+        <p:spPr/>
+        <p:txBody>
+          <a:bodyPr/>
+          <a:lstStyle/>
+          <a:p>
+            <a:r>
+              <a:rPr lang="en-US" dirty="0"/>
+              <a:t>Delivery Time &amp; Customer Reviews</a:t>
+            </a:r>
+          </a:p>
+        </p:txBody>
+      </p:sp>
+      <p:sp>
+        <p:nvSpPr>
+          <p:cNvPr id="3" name="Text Placeholder 2">
+            <a:extLst>
+              <a:ext uri="{FF2B5EF4-FFF2-40B4-BE49-F238E27FC236}">
+                <a16:creationId xmlns:a16="http://schemas.microsoft.com/office/drawing/2014/main" id="{3B5E2797-167C-8E8B-B485-E71790C6E69C}"/>
+              </a:ext>
+            </a:extLst>
+          </p:cNvPr>
+          <p:cNvSpPr>
+            <a:spLocks noGrp="1"/>
+          </p:cNvSpPr>
+          <p:nvPr>
+            <p:ph type="body" idx="1"/>
+          </p:nvPr>
+        </p:nvSpPr>
+        <p:spPr/>
+        <p:txBody>
+          <a:bodyPr/>
+          <a:lstStyle/>
+          <a:p>
+            <a:r>
+              <a:rPr lang="en-US" dirty="0"/>
+              <a:t>Q5</a:t>
+            </a:r>
+          </a:p>
+        </p:txBody>
+      </p:sp>
+      <p:sp>
+        <p:nvSpPr>
+          <p:cNvPr id="4" name="Content Placeholder 3">
+            <a:extLst>
+              <a:ext uri="{FF2B5EF4-FFF2-40B4-BE49-F238E27FC236}">
+                <a16:creationId xmlns:a16="http://schemas.microsoft.com/office/drawing/2014/main" id="{E72F4CE0-5F18-E6DB-A60B-95D50722AD46}"/>
+              </a:ext>
+            </a:extLst>
+          </p:cNvPr>
+          <p:cNvSpPr>
+            <a:spLocks noGrp="1"/>
+          </p:cNvSpPr>
+          <p:nvPr>
+            <p:ph sz="half" idx="2"/>
+          </p:nvPr>
+        </p:nvSpPr>
+        <p:spPr/>
+        <p:txBody>
+          <a:bodyPr/>
+          <a:lstStyle/>
+          <a:p>
+            <a:r>
+              <a:rPr lang="en-US" dirty="0"/>
+              <a:t>TODO</a:t>
+            </a:r>
+          </a:p>
+        </p:txBody>
+      </p:sp>
+      <p:sp>
+        <p:nvSpPr>
+          <p:cNvPr id="5" name="Text Placeholder 4">
+            <a:extLst>
+              <a:ext uri="{FF2B5EF4-FFF2-40B4-BE49-F238E27FC236}">
+                <a16:creationId xmlns:a16="http://schemas.microsoft.com/office/drawing/2014/main" id="{5F0F5418-56A8-AEE0-C231-11278121AA9D}"/>
+              </a:ext>
+            </a:extLst>
+          </p:cNvPr>
+          <p:cNvSpPr>
+            <a:spLocks noGrp="1"/>
+          </p:cNvSpPr>
+          <p:nvPr>
+            <p:ph type="body" sz="quarter" idx="3"/>
+          </p:nvPr>
+        </p:nvSpPr>
+        <p:spPr/>
+        <p:txBody>
+          <a:bodyPr/>
+          <a:lstStyle/>
+          <a:p>
+            <a:r>
+              <a:rPr lang="en-US" dirty="0"/>
+              <a:t>Q6</a:t>
+            </a:r>
+          </a:p>
+        </p:txBody>
+      </p:sp>
+      <p:sp>
+        <p:nvSpPr>
+          <p:cNvPr id="6" name="Content Placeholder 5">
+            <a:extLst>
+              <a:ext uri="{FF2B5EF4-FFF2-40B4-BE49-F238E27FC236}">
+                <a16:creationId xmlns:a16="http://schemas.microsoft.com/office/drawing/2014/main" id="{2EF9F847-1D46-C17E-05CA-C013095844DE}"/>
+              </a:ext>
+            </a:extLst>
+          </p:cNvPr>
+          <p:cNvSpPr>
+            <a:spLocks noGrp="1"/>
+          </p:cNvSpPr>
+          <p:nvPr>
+            <p:ph sz="quarter" idx="4"/>
+          </p:nvPr>
+        </p:nvSpPr>
+        <p:spPr/>
+        <p:txBody>
+          <a:bodyPr/>
+          <a:lstStyle/>
+          <a:p>
+            <a:r>
+              <a:rPr lang="en-US" dirty="0"/>
+              <a:t>TODO</a:t>
+            </a:r>
+          </a:p>
+        </p:txBody>
+      </p:sp>
+    </p:spTree>
+    <p:extLst>
+      <p:ext uri="{BB962C8B-B14F-4D97-AF65-F5344CB8AC3E}">
+        <p14:creationId xmlns:p14="http://schemas.microsoft.com/office/powerpoint/2010/main" val="296423964"/>
+      </p:ext>
+    </p:extLst>
+  </p:cSld>
+  <p:clrMapOvr>
+    <a:masterClrMapping/>
+  </p:clrMapOvr>
+</p:sld>
+</file>
+
+<file path=ppt/slides/slide12.xml><?xml version="1.0" encoding="utf-8"?>
+<p:sld xmlns:a="http://schemas.openxmlformats.org/drawingml/2006/main" xmlns:r="http://schemas.openxmlformats.org/officeDocument/2006/relationships" xmlns:p="http://schemas.openxmlformats.org/presentationml/2006/main">
+  <p:cSld>
+    <p:spTree>
+      <p:nvGrpSpPr>
+        <p:cNvPr id="1" name=""/>
+        <p:cNvGrpSpPr/>
+        <p:nvPr/>
+      </p:nvGrpSpPr>
+      <p:grpSpPr>
+        <a:xfrm>
+          <a:off x="0" y="0"/>
+          <a:ext cx="0" cy="0"/>
+          <a:chOff x="0" y="0"/>
+          <a:chExt cx="0" cy="0"/>
+        </a:xfrm>
+      </p:grpSpPr>
+      <p:sp>
+        <p:nvSpPr>
+          <p:cNvPr id="2" name="Title 1">
+            <a:extLst>
+              <a:ext uri="{FF2B5EF4-FFF2-40B4-BE49-F238E27FC236}">
+                <a16:creationId xmlns:a16="http://schemas.microsoft.com/office/drawing/2014/main" id="{F9406560-2801-DF72-748D-88EA669A4A43}"/>
+              </a:ext>
+            </a:extLst>
+          </p:cNvPr>
+          <p:cNvSpPr>
+            <a:spLocks noGrp="1"/>
+          </p:cNvSpPr>
+          <p:nvPr>
+            <p:ph type="title"/>
+          </p:nvPr>
+        </p:nvSpPr>
+        <p:spPr/>
+        <p:txBody>
+          <a:bodyPr/>
+          <a:lstStyle/>
+          <a:p>
+            <a:r>
+              <a:rPr lang="en-US" dirty="0"/>
+              <a:t>Order Insights</a:t>
+            </a:r>
+          </a:p>
+        </p:txBody>
+      </p:sp>
+      <p:sp>
+        <p:nvSpPr>
+          <p:cNvPr id="3" name="Text Placeholder 2">
+            <a:extLst>
+              <a:ext uri="{FF2B5EF4-FFF2-40B4-BE49-F238E27FC236}">
+                <a16:creationId xmlns:a16="http://schemas.microsoft.com/office/drawing/2014/main" id="{BF3F6C46-87BA-B4DA-4388-4B98932BFA35}"/>
+              </a:ext>
+            </a:extLst>
+          </p:cNvPr>
+          <p:cNvSpPr>
+            <a:spLocks noGrp="1"/>
+          </p:cNvSpPr>
+          <p:nvPr>
+            <p:ph type="body" idx="1"/>
+          </p:nvPr>
+        </p:nvSpPr>
+        <p:spPr/>
+        <p:txBody>
+          <a:bodyPr/>
+          <a:lstStyle/>
+          <a:p>
+            <a:r>
+              <a:rPr lang="en-US" dirty="0"/>
+              <a:t>Q7</a:t>
+            </a:r>
+          </a:p>
+        </p:txBody>
+      </p:sp>
+      <p:sp>
+        <p:nvSpPr>
+          <p:cNvPr id="4" name="Content Placeholder 3">
+            <a:extLst>
+              <a:ext uri="{FF2B5EF4-FFF2-40B4-BE49-F238E27FC236}">
+                <a16:creationId xmlns:a16="http://schemas.microsoft.com/office/drawing/2014/main" id="{3A9AED6A-86DC-694C-C636-2D6D387EEB7D}"/>
+              </a:ext>
+            </a:extLst>
+          </p:cNvPr>
+          <p:cNvSpPr>
+            <a:spLocks noGrp="1"/>
+          </p:cNvSpPr>
+          <p:nvPr>
+            <p:ph sz="half" idx="2"/>
+          </p:nvPr>
+        </p:nvSpPr>
+        <p:spPr/>
+        <p:txBody>
+          <a:bodyPr/>
+          <a:lstStyle/>
+          <a:p>
+            <a:r>
+              <a:rPr lang="en-US" dirty="0"/>
+              <a:t>TODO</a:t>
+            </a:r>
+          </a:p>
+        </p:txBody>
+      </p:sp>
+      <p:sp>
+        <p:nvSpPr>
+          <p:cNvPr id="5" name="Text Placeholder 4">
+            <a:extLst>
+              <a:ext uri="{FF2B5EF4-FFF2-40B4-BE49-F238E27FC236}">
+                <a16:creationId xmlns:a16="http://schemas.microsoft.com/office/drawing/2014/main" id="{5AFE4C2F-7FAD-2628-CE31-14ADE076AB8B}"/>
+              </a:ext>
+            </a:extLst>
+          </p:cNvPr>
+          <p:cNvSpPr>
+            <a:spLocks noGrp="1"/>
+          </p:cNvSpPr>
+          <p:nvPr>
+            <p:ph type="body" sz="quarter" idx="3"/>
+          </p:nvPr>
+        </p:nvSpPr>
+        <p:spPr/>
+        <p:txBody>
+          <a:bodyPr/>
+          <a:lstStyle/>
+          <a:p>
+            <a:r>
+              <a:rPr lang="en-US" dirty="0"/>
+              <a:t>Q8</a:t>
+            </a:r>
+          </a:p>
+        </p:txBody>
+      </p:sp>
+      <p:sp>
+        <p:nvSpPr>
+          <p:cNvPr id="6" name="Content Placeholder 5">
+            <a:extLst>
+              <a:ext uri="{FF2B5EF4-FFF2-40B4-BE49-F238E27FC236}">
+                <a16:creationId xmlns:a16="http://schemas.microsoft.com/office/drawing/2014/main" id="{86BFE0CA-2E02-792F-8BE4-233204DDE9A5}"/>
+              </a:ext>
+            </a:extLst>
+          </p:cNvPr>
+          <p:cNvSpPr>
+            <a:spLocks noGrp="1"/>
+          </p:cNvSpPr>
+          <p:nvPr>
+            <p:ph sz="quarter" idx="4"/>
+          </p:nvPr>
+        </p:nvSpPr>
+        <p:spPr/>
+        <p:txBody>
+          <a:bodyPr/>
+          <a:lstStyle/>
+          <a:p>
+            <a:r>
+              <a:rPr lang="en-US" dirty="0"/>
+              <a:t>TODO</a:t>
+            </a:r>
+          </a:p>
+        </p:txBody>
+      </p:sp>
+    </p:spTree>
+    <p:extLst>
+      <p:ext uri="{BB962C8B-B14F-4D97-AF65-F5344CB8AC3E}">
+        <p14:creationId xmlns:p14="http://schemas.microsoft.com/office/powerpoint/2010/main" val="3907987761"/>
+      </p:ext>
+    </p:extLst>
+  </p:cSld>
+  <p:clrMapOvr>
+    <a:masterClrMapping/>
+  </p:clrMapOvr>
+</p:sld>
+</file>
+
+<file path=ppt/slides/slide13.xml><?xml version="1.0" encoding="utf-8"?>
+<p:sld xmlns:a="http://schemas.openxmlformats.org/drawingml/2006/main" xmlns:r="http://schemas.openxmlformats.org/officeDocument/2006/relationships" xmlns:p="http://schemas.openxmlformats.org/presentationml/2006/main">
+  <p:cSld>
+    <p:spTree>
+      <p:nvGrpSpPr>
         <p:cNvPr id="1" name="">
           <a:extLst>
             <a:ext uri="{FF2B5EF4-FFF2-40B4-BE49-F238E27FC236}">
@@ -21616,7 +22911,7 @@
 </p:sld>
 </file>
 
-<file path=ppt/slides/slide11.xml><?xml version="1.0" encoding="utf-8"?>
+<file path=ppt/slides/slide14.xml><?xml version="1.0" encoding="utf-8"?>
 <p:sld xmlns:a="http://schemas.openxmlformats.org/drawingml/2006/main" xmlns:r="http://schemas.openxmlformats.org/officeDocument/2006/relationships" xmlns:p="http://schemas.openxmlformats.org/presentationml/2006/main">
   <p:cSld>
     <p:spTree>
@@ -21792,7 +23087,7 @@
 </p:sld>
 </file>
 
-<file path=ppt/slides/slide12.xml><?xml version="1.0" encoding="utf-8"?>
+<file path=ppt/slides/slide15.xml><?xml version="1.0" encoding="utf-8"?>
 <p:sld xmlns:a="http://schemas.openxmlformats.org/drawingml/2006/main" xmlns:r="http://schemas.openxmlformats.org/officeDocument/2006/relationships" xmlns:p="http://schemas.openxmlformats.org/presentationml/2006/main">
   <p:cSld>
     <p:spTree>
@@ -21968,7 +23263,7 @@
 </p:sld>
 </file>
 
-<file path=ppt/slides/slide13.xml><?xml version="1.0" encoding="utf-8"?>
+<file path=ppt/slides/slide16.xml><?xml version="1.0" encoding="utf-8"?>
 <p:sld xmlns:a="http://schemas.openxmlformats.org/drawingml/2006/main" xmlns:r="http://schemas.openxmlformats.org/officeDocument/2006/relationships" xmlns:p="http://schemas.openxmlformats.org/presentationml/2006/main">
   <p:cSld>
     <p:spTree>
@@ -22082,7 +23377,7 @@
 </p:sld>
 </file>
 
-<file path=ppt/slides/slide14.xml><?xml version="1.0" encoding="utf-8"?>
+<file path=ppt/slides/slide17.xml><?xml version="1.0" encoding="utf-8"?>
 <p:sld xmlns:a="http://schemas.openxmlformats.org/drawingml/2006/main" xmlns:r="http://schemas.openxmlformats.org/officeDocument/2006/relationships" xmlns:p="http://schemas.openxmlformats.org/presentationml/2006/main">
   <p:cSld>
     <p:spTree>
@@ -22140,7 +23435,7 @@
 </p:sld>
 </file>
 
-<file path=ppt/slides/slide15.xml><?xml version="1.0" encoding="utf-8"?>
+<file path=ppt/slides/slide18.xml><?xml version="1.0" encoding="utf-8"?>
 <p:sld xmlns:a="http://schemas.openxmlformats.org/drawingml/2006/main" xmlns:r="http://schemas.openxmlformats.org/officeDocument/2006/relationships" xmlns:p="http://schemas.openxmlformats.org/presentationml/2006/main">
   <p:cSld>
     <p:spTree>
@@ -22198,7 +23493,7 @@
 </p:sld>
 </file>
 
-<file path=ppt/slides/slide16.xml><?xml version="1.0" encoding="utf-8"?>
+<file path=ppt/slides/slide19.xml><?xml version="1.0" encoding="utf-8"?>
 <p:sld xmlns:a="http://schemas.openxmlformats.org/drawingml/2006/main" xmlns:r="http://schemas.openxmlformats.org/officeDocument/2006/relationships" xmlns:p="http://schemas.openxmlformats.org/presentationml/2006/main">
   <p:cSld>
     <p:spTree>
@@ -22262,7 +23557,223 @@
 </p:sld>
 </file>
 
-<file path=ppt/slides/slide17.xml><?xml version="1.0" encoding="utf-8"?>
+<file path=ppt/slides/slide2.xml><?xml version="1.0" encoding="utf-8"?>
+<p:sld xmlns:a="http://schemas.openxmlformats.org/drawingml/2006/main" xmlns:r="http://schemas.openxmlformats.org/officeDocument/2006/relationships" xmlns:p="http://schemas.openxmlformats.org/presentationml/2006/main">
+  <p:cSld>
+    <p:spTree>
+      <p:nvGrpSpPr>
+        <p:cNvPr id="1" name=""/>
+        <p:cNvGrpSpPr/>
+        <p:nvPr/>
+      </p:nvGrpSpPr>
+      <p:grpSpPr>
+        <a:xfrm>
+          <a:off x="0" y="0"/>
+          <a:ext cx="0" cy="0"/>
+          <a:chOff x="0" y="0"/>
+          <a:chExt cx="0" cy="0"/>
+        </a:xfrm>
+      </p:grpSpPr>
+      <p:sp>
+        <p:nvSpPr>
+          <p:cNvPr id="4" name="Title 3">
+            <a:extLst>
+              <a:ext uri="{FF2B5EF4-FFF2-40B4-BE49-F238E27FC236}">
+                <a16:creationId xmlns:a16="http://schemas.microsoft.com/office/drawing/2014/main" id="{B1BD08D1-A20C-8824-49BF-4AD31207C703}"/>
+              </a:ext>
+            </a:extLst>
+          </p:cNvPr>
+          <p:cNvSpPr>
+            <a:spLocks noGrp="1"/>
+          </p:cNvSpPr>
+          <p:nvPr>
+            <p:ph type="title"/>
+          </p:nvPr>
+        </p:nvSpPr>
+        <p:spPr/>
+        <p:txBody>
+          <a:bodyPr/>
+          <a:lstStyle/>
+          <a:p>
+            <a:r>
+              <a:rPr lang="en-US" dirty="0"/>
+              <a:t>Overview</a:t>
+            </a:r>
+          </a:p>
+        </p:txBody>
+      </p:sp>
+      <p:sp>
+        <p:nvSpPr>
+          <p:cNvPr id="7" name="Text Placeholder 6">
+            <a:extLst>
+              <a:ext uri="{FF2B5EF4-FFF2-40B4-BE49-F238E27FC236}">
+                <a16:creationId xmlns:a16="http://schemas.microsoft.com/office/drawing/2014/main" id="{B469FF13-3531-629D-F396-B0DEF3786080}"/>
+              </a:ext>
+            </a:extLst>
+          </p:cNvPr>
+          <p:cNvSpPr>
+            <a:spLocks noGrp="1"/>
+          </p:cNvSpPr>
+          <p:nvPr>
+            <p:ph type="body" idx="1"/>
+          </p:nvPr>
+        </p:nvSpPr>
+        <p:spPr/>
+        <p:txBody>
+          <a:bodyPr/>
+          <a:lstStyle/>
+          <a:p>
+            <a:r>
+              <a:rPr lang="en-US" dirty="0"/>
+              <a:t>About the Dataset</a:t>
+            </a:r>
+          </a:p>
+        </p:txBody>
+      </p:sp>
+      <p:sp>
+        <p:nvSpPr>
+          <p:cNvPr id="5" name="Content Placeholder 4">
+            <a:extLst>
+              <a:ext uri="{FF2B5EF4-FFF2-40B4-BE49-F238E27FC236}">
+                <a16:creationId xmlns:a16="http://schemas.microsoft.com/office/drawing/2014/main" id="{24CF210F-1633-099E-EDC2-40945E14CCB4}"/>
+              </a:ext>
+            </a:extLst>
+          </p:cNvPr>
+          <p:cNvSpPr>
+            <a:spLocks noGrp="1"/>
+          </p:cNvSpPr>
+          <p:nvPr>
+            <p:ph sz="half" idx="2"/>
+          </p:nvPr>
+        </p:nvSpPr>
+        <p:spPr/>
+        <p:txBody>
+          <a:bodyPr>
+            <a:normAutofit/>
+          </a:bodyPr>
+          <a:lstStyle/>
+          <a:p>
+            <a:r>
+              <a:rPr lang="en-US" b="1" dirty="0"/>
+              <a:t>Brazilian e-commerce marketplace</a:t>
+            </a:r>
+            <a:r>
+              <a:rPr lang="en-US" dirty="0"/>
+              <a:t>, data collected January 2017 – August 2018</a:t>
+            </a:r>
+          </a:p>
+          <a:p>
+            <a:r>
+              <a:rPr lang="en-US" dirty="0"/>
+              <a:t>11 tables | ~1.56 million rows</a:t>
+            </a:r>
+          </a:p>
+          <a:p>
+            <a:r>
+              <a:rPr lang="en-US" dirty="0"/>
+              <a:t>Orders, customers, sellers, products, payments, reviews, marketing leads</a:t>
+            </a:r>
+          </a:p>
+        </p:txBody>
+      </p:sp>
+      <p:sp>
+        <p:nvSpPr>
+          <p:cNvPr id="8" name="Text Placeholder 7">
+            <a:extLst>
+              <a:ext uri="{FF2B5EF4-FFF2-40B4-BE49-F238E27FC236}">
+                <a16:creationId xmlns:a16="http://schemas.microsoft.com/office/drawing/2014/main" id="{191E1A53-C0C9-652E-D895-46D5E3F7287E}"/>
+              </a:ext>
+            </a:extLst>
+          </p:cNvPr>
+          <p:cNvSpPr>
+            <a:spLocks noGrp="1"/>
+          </p:cNvSpPr>
+          <p:nvPr>
+            <p:ph type="body" sz="quarter" idx="3"/>
+          </p:nvPr>
+        </p:nvSpPr>
+        <p:spPr/>
+        <p:txBody>
+          <a:bodyPr/>
+          <a:lstStyle/>
+          <a:p>
+            <a:r>
+              <a:rPr lang="en-US" dirty="0"/>
+              <a:t>Goal</a:t>
+            </a:r>
+          </a:p>
+        </p:txBody>
+      </p:sp>
+      <p:sp>
+        <p:nvSpPr>
+          <p:cNvPr id="6" name="Content Placeholder 5">
+            <a:extLst>
+              <a:ext uri="{FF2B5EF4-FFF2-40B4-BE49-F238E27FC236}">
+                <a16:creationId xmlns:a16="http://schemas.microsoft.com/office/drawing/2014/main" id="{FD210212-EDE2-D982-0ED2-33A80E851551}"/>
+              </a:ext>
+            </a:extLst>
+          </p:cNvPr>
+          <p:cNvSpPr>
+            <a:spLocks noGrp="1"/>
+          </p:cNvSpPr>
+          <p:nvPr>
+            <p:ph sz="quarter" idx="4"/>
+          </p:nvPr>
+        </p:nvSpPr>
+        <p:spPr/>
+        <p:txBody>
+          <a:bodyPr>
+            <a:normAutofit/>
+          </a:bodyPr>
+          <a:lstStyle/>
+          <a:p>
+            <a:r>
+              <a:rPr lang="en-US" dirty="0"/>
+              <a:t>Analyze </a:t>
+            </a:r>
+            <a:r>
+              <a:rPr lang="en-US" b="1" dirty="0"/>
+              <a:t>sales performance and customer behavior</a:t>
+            </a:r>
+            <a:r>
+              <a:rPr lang="en-US" dirty="0"/>
+              <a:t> in a large e‑commerce marketplace</a:t>
+            </a:r>
+          </a:p>
+          <a:p>
+            <a:r>
+              <a:rPr lang="en-US" dirty="0"/>
+              <a:t>Jan: Sales &amp; Revenue (Q01–Q04)</a:t>
+            </a:r>
+          </a:p>
+          <a:p>
+            <a:r>
+              <a:rPr lang="en-US" dirty="0"/>
+              <a:t>Michael: Customer &amp; Delivery Behavior (Q05–Q08)</a:t>
+            </a:r>
+          </a:p>
+          <a:p>
+            <a:r>
+              <a:rPr lang="en-US" dirty="0"/>
+              <a:t>Vanessa: Seller &amp; Product Performance (Q09–Q12)</a:t>
+            </a:r>
+          </a:p>
+        </p:txBody>
+      </p:sp>
+    </p:spTree>
+    <p:extLst>
+      <p:ext uri="{BB962C8B-B14F-4D97-AF65-F5344CB8AC3E}">
+        <p14:creationId xmlns:p14="http://schemas.microsoft.com/office/powerpoint/2010/main" val="486327789"/>
+      </p:ext>
+    </p:extLst>
+  </p:cSld>
+  <p:clrMapOvr>
+    <a:masterClrMapping/>
+  </p:clrMapOvr>
+</p:sld>
+</file>
+
+<file path=ppt/slides/slide20.xml><?xml version="1.0" encoding="utf-8"?>
 <p:sld xmlns:a="http://schemas.openxmlformats.org/drawingml/2006/main" xmlns:r="http://schemas.openxmlformats.org/officeDocument/2006/relationships" xmlns:p="http://schemas.openxmlformats.org/presentationml/2006/main">
   <p:cSld>
     <p:spTree>
@@ -22320,7 +23831,7 @@
 </p:sld>
 </file>
 
-<file path=ppt/slides/slide18.xml><?xml version="1.0" encoding="utf-8"?>
+<file path=ppt/slides/slide21.xml><?xml version="1.0" encoding="utf-8"?>
 <p:sld xmlns:a="http://schemas.openxmlformats.org/drawingml/2006/main" xmlns:r="http://schemas.openxmlformats.org/officeDocument/2006/relationships" xmlns:p="http://schemas.openxmlformats.org/presentationml/2006/main">
   <p:cSld>
     <p:spTree>
@@ -22412,7 +23923,7 @@
 </p:sld>
 </file>
 
-<file path=ppt/slides/slide19.xml><?xml version="1.0" encoding="utf-8"?>
+<file path=ppt/slides/slide22.xml><?xml version="1.0" encoding="utf-8"?>
 <p:sld xmlns:a="http://schemas.openxmlformats.org/drawingml/2006/main" xmlns:r="http://schemas.openxmlformats.org/officeDocument/2006/relationships" xmlns:p="http://schemas.openxmlformats.org/presentationml/2006/main">
   <p:cSld>
     <p:spTree>
@@ -24153,219 +25664,7 @@
 </p:sld>
 </file>
 
-<file path=ppt/slides/slide2.xml><?xml version="1.0" encoding="utf-8"?>
-<p:sld xmlns:a="http://schemas.openxmlformats.org/drawingml/2006/main" xmlns:r="http://schemas.openxmlformats.org/officeDocument/2006/relationships" xmlns:p="http://schemas.openxmlformats.org/presentationml/2006/main">
-  <p:cSld>
-    <p:spTree>
-      <p:nvGrpSpPr>
-        <p:cNvPr id="1" name=""/>
-        <p:cNvGrpSpPr/>
-        <p:nvPr/>
-      </p:nvGrpSpPr>
-      <p:grpSpPr>
-        <a:xfrm>
-          <a:off x="0" y="0"/>
-          <a:ext cx="0" cy="0"/>
-          <a:chOff x="0" y="0"/>
-          <a:chExt cx="0" cy="0"/>
-        </a:xfrm>
-      </p:grpSpPr>
-      <p:sp>
-        <p:nvSpPr>
-          <p:cNvPr id="4" name="Title 3">
-            <a:extLst>
-              <a:ext uri="{FF2B5EF4-FFF2-40B4-BE49-F238E27FC236}">
-                <a16:creationId xmlns:a16="http://schemas.microsoft.com/office/drawing/2014/main" id="{B1BD08D1-A20C-8824-49BF-4AD31207C703}"/>
-              </a:ext>
-            </a:extLst>
-          </p:cNvPr>
-          <p:cNvSpPr>
-            <a:spLocks noGrp="1"/>
-          </p:cNvSpPr>
-          <p:nvPr>
-            <p:ph type="title"/>
-          </p:nvPr>
-        </p:nvSpPr>
-        <p:spPr/>
-        <p:txBody>
-          <a:bodyPr/>
-          <a:lstStyle/>
-          <a:p>
-            <a:r>
-              <a:rPr lang="en-US" dirty="0"/>
-              <a:t>Overview</a:t>
-            </a:r>
-          </a:p>
-        </p:txBody>
-      </p:sp>
-      <p:sp>
-        <p:nvSpPr>
-          <p:cNvPr id="7" name="Text Placeholder 6">
-            <a:extLst>
-              <a:ext uri="{FF2B5EF4-FFF2-40B4-BE49-F238E27FC236}">
-                <a16:creationId xmlns:a16="http://schemas.microsoft.com/office/drawing/2014/main" id="{B469FF13-3531-629D-F396-B0DEF3786080}"/>
-              </a:ext>
-            </a:extLst>
-          </p:cNvPr>
-          <p:cNvSpPr>
-            <a:spLocks noGrp="1"/>
-          </p:cNvSpPr>
-          <p:nvPr>
-            <p:ph type="body" idx="1"/>
-          </p:nvPr>
-        </p:nvSpPr>
-        <p:spPr/>
-        <p:txBody>
-          <a:bodyPr/>
-          <a:lstStyle/>
-          <a:p>
-            <a:r>
-              <a:rPr lang="en-US" dirty="0"/>
-              <a:t>About the Dataset</a:t>
-            </a:r>
-          </a:p>
-        </p:txBody>
-      </p:sp>
-      <p:sp>
-        <p:nvSpPr>
-          <p:cNvPr id="5" name="Content Placeholder 4">
-            <a:extLst>
-              <a:ext uri="{FF2B5EF4-FFF2-40B4-BE49-F238E27FC236}">
-                <a16:creationId xmlns:a16="http://schemas.microsoft.com/office/drawing/2014/main" id="{24CF210F-1633-099E-EDC2-40945E14CCB4}"/>
-              </a:ext>
-            </a:extLst>
-          </p:cNvPr>
-          <p:cNvSpPr>
-            <a:spLocks noGrp="1"/>
-          </p:cNvSpPr>
-          <p:nvPr>
-            <p:ph sz="half" idx="2"/>
-          </p:nvPr>
-        </p:nvSpPr>
-        <p:spPr/>
-        <p:txBody>
-          <a:bodyPr>
-            <a:normAutofit/>
-          </a:bodyPr>
-          <a:lstStyle/>
-          <a:p>
-            <a:r>
-              <a:rPr lang="en-US" dirty="0"/>
-              <a:t>Brazilian e-commerce marketplace, 2016–2018</a:t>
-            </a:r>
-          </a:p>
-          <a:p>
-            <a:r>
-              <a:rPr lang="en-US" dirty="0"/>
-              <a:t>11 tables | ~1.56 million rows</a:t>
-            </a:r>
-          </a:p>
-          <a:p>
-            <a:r>
-              <a:rPr lang="en-US" dirty="0"/>
-              <a:t>Orders, customers, sellers, products, payments, reviews, marketing leads</a:t>
-            </a:r>
-          </a:p>
-        </p:txBody>
-      </p:sp>
-      <p:sp>
-        <p:nvSpPr>
-          <p:cNvPr id="8" name="Text Placeholder 7">
-            <a:extLst>
-              <a:ext uri="{FF2B5EF4-FFF2-40B4-BE49-F238E27FC236}">
-                <a16:creationId xmlns:a16="http://schemas.microsoft.com/office/drawing/2014/main" id="{191E1A53-C0C9-652E-D895-46D5E3F7287E}"/>
-              </a:ext>
-            </a:extLst>
-          </p:cNvPr>
-          <p:cNvSpPr>
-            <a:spLocks noGrp="1"/>
-          </p:cNvSpPr>
-          <p:nvPr>
-            <p:ph type="body" sz="quarter" idx="3"/>
-          </p:nvPr>
-        </p:nvSpPr>
-        <p:spPr/>
-        <p:txBody>
-          <a:bodyPr/>
-          <a:lstStyle/>
-          <a:p>
-            <a:r>
-              <a:rPr lang="en-US" dirty="0"/>
-              <a:t>Goal</a:t>
-            </a:r>
-          </a:p>
-        </p:txBody>
-      </p:sp>
-      <p:sp>
-        <p:nvSpPr>
-          <p:cNvPr id="6" name="Content Placeholder 5">
-            <a:extLst>
-              <a:ext uri="{FF2B5EF4-FFF2-40B4-BE49-F238E27FC236}">
-                <a16:creationId xmlns:a16="http://schemas.microsoft.com/office/drawing/2014/main" id="{FD210212-EDE2-D982-0ED2-33A80E851551}"/>
-              </a:ext>
-            </a:extLst>
-          </p:cNvPr>
-          <p:cNvSpPr>
-            <a:spLocks noGrp="1"/>
-          </p:cNvSpPr>
-          <p:nvPr>
-            <p:ph sz="quarter" idx="4"/>
-          </p:nvPr>
-        </p:nvSpPr>
-        <p:spPr/>
-        <p:txBody>
-          <a:bodyPr>
-            <a:normAutofit/>
-          </a:bodyPr>
-          <a:lstStyle/>
-          <a:p>
-            <a:r>
-              <a:rPr lang="en-US" dirty="0"/>
-              <a:t>Analyze Sales performance and customer behavior in a </a:t>
-            </a:r>
-            <a:r>
-              <a:rPr lang="en-US"/>
-              <a:t>large e‑commerce </a:t>
-            </a:r>
-            <a:r>
-              <a:rPr lang="en-US" dirty="0"/>
-              <a:t>marketplace</a:t>
-            </a:r>
-          </a:p>
-          <a:p>
-            <a:r>
-              <a:rPr lang="en-US" dirty="0"/>
-              <a:t>Jan: Sales &amp; Revenue (Q01–Q04)</a:t>
-            </a:r>
-          </a:p>
-          <a:p>
-            <a:r>
-              <a:rPr lang="en-US" dirty="0"/>
-              <a:t>Michael: Customer &amp; Delivery Behavior (Q05–Q08)</a:t>
-            </a:r>
-          </a:p>
-          <a:p>
-            <a:r>
-              <a:rPr lang="en-US" dirty="0"/>
-              <a:t>Vanessa: Seller &amp; Product Performance (Q09–Q12)</a:t>
-            </a:r>
-          </a:p>
-        </p:txBody>
-      </p:sp>
-    </p:spTree>
-    <p:extLst>
-      <p:ext uri="{BB962C8B-B14F-4D97-AF65-F5344CB8AC3E}">
-        <p14:creationId xmlns:p14="http://schemas.microsoft.com/office/powerpoint/2010/main" val="486327789"/>
-      </p:ext>
-    </p:extLst>
-  </p:cSld>
-  <p:clrMapOvr>
-    <a:masterClrMapping/>
-  </p:clrMapOvr>
-</p:sld>
-</file>
-
-<file path=ppt/slides/slide20.xml><?xml version="1.0" encoding="utf-8"?>
+<file path=ppt/slides/slide23.xml><?xml version="1.0" encoding="utf-8"?>
 <p:sld xmlns:a="http://schemas.openxmlformats.org/drawingml/2006/main" xmlns:r="http://schemas.openxmlformats.org/officeDocument/2006/relationships" xmlns:p="http://schemas.openxmlformats.org/presentationml/2006/main">
   <p:cSld>
     <p:spTree>
@@ -24478,7 +25777,7 @@
 </p:sld>
 </file>
 
-<file path=ppt/slides/slide21.xml><?xml version="1.0" encoding="utf-8"?>
+<file path=ppt/slides/slide24.xml><?xml version="1.0" encoding="utf-8"?>
 <p:sld xmlns:a="http://schemas.openxmlformats.org/drawingml/2006/main" xmlns:r="http://schemas.openxmlformats.org/officeDocument/2006/relationships" xmlns:p="http://schemas.openxmlformats.org/presentationml/2006/main">
   <p:cSld>
     <p:spTree>
@@ -24562,6 +25861,312 @@
 </file>
 
 <file path=ppt/slides/slide3.xml><?xml version="1.0" encoding="utf-8"?>
+<p:sld xmlns:a="http://schemas.openxmlformats.org/drawingml/2006/main" xmlns:r="http://schemas.openxmlformats.org/officeDocument/2006/relationships" xmlns:p="http://schemas.openxmlformats.org/presentationml/2006/main">
+  <p:cSld>
+    <p:spTree>
+      <p:nvGrpSpPr>
+        <p:cNvPr id="1" name=""/>
+        <p:cNvGrpSpPr/>
+        <p:nvPr/>
+      </p:nvGrpSpPr>
+      <p:grpSpPr>
+        <a:xfrm>
+          <a:off x="0" y="0"/>
+          <a:ext cx="0" cy="0"/>
+          <a:chOff x="0" y="0"/>
+          <a:chExt cx="0" cy="0"/>
+        </a:xfrm>
+      </p:grpSpPr>
+      <p:sp>
+        <p:nvSpPr>
+          <p:cNvPr id="2" name="Title 1">
+            <a:extLst>
+              <a:ext uri="{FF2B5EF4-FFF2-40B4-BE49-F238E27FC236}">
+                <a16:creationId xmlns:a16="http://schemas.microsoft.com/office/drawing/2014/main" id="{210C8AC0-62E9-57DD-DC84-99F7E9D64E63}"/>
+              </a:ext>
+            </a:extLst>
+          </p:cNvPr>
+          <p:cNvSpPr>
+            <a:spLocks noGrp="1"/>
+          </p:cNvSpPr>
+          <p:nvPr>
+            <p:ph type="title"/>
+          </p:nvPr>
+        </p:nvSpPr>
+        <p:spPr/>
+        <p:txBody>
+          <a:bodyPr/>
+          <a:lstStyle/>
+          <a:p>
+            <a:r>
+              <a:rPr lang="it-IT" dirty="0"/>
+              <a:t>Data Pipeline: SQLite → SQL Server</a:t>
+            </a:r>
+            <a:endParaRPr lang="en-US" dirty="0"/>
+          </a:p>
+        </p:txBody>
+      </p:sp>
+      <p:sp>
+        <p:nvSpPr>
+          <p:cNvPr id="3" name="Content Placeholder 2">
+            <a:extLst>
+              <a:ext uri="{FF2B5EF4-FFF2-40B4-BE49-F238E27FC236}">
+                <a16:creationId xmlns:a16="http://schemas.microsoft.com/office/drawing/2014/main" id="{A92CA810-54C5-D62B-F075-194CB2D39CB3}"/>
+              </a:ext>
+            </a:extLst>
+          </p:cNvPr>
+          <p:cNvSpPr>
+            <a:spLocks noGrp="1"/>
+          </p:cNvSpPr>
+          <p:nvPr>
+            <p:ph idx="1"/>
+          </p:nvPr>
+        </p:nvSpPr>
+        <p:spPr/>
+        <p:txBody>
+          <a:bodyPr>
+            <a:normAutofit lnSpcReduction="10000"/>
+          </a:bodyPr>
+          <a:lstStyle/>
+          <a:p>
+            <a:r>
+              <a:rPr lang="en-US" dirty="0"/>
+              <a:t>Source: single-file </a:t>
+            </a:r>
+            <a:r>
+              <a:rPr lang="en-US" b="1" dirty="0"/>
+              <a:t>SQLite</a:t>
+            </a:r>
+            <a:r>
+              <a:rPr lang="en-US" dirty="0"/>
+              <a:t> database (110 MB)</a:t>
+            </a:r>
+          </a:p>
+          <a:p>
+            <a:r>
+              <a:rPr lang="en-US" b="1" dirty="0"/>
+              <a:t>Python script:</a:t>
+            </a:r>
+          </a:p>
+          <a:p>
+            <a:pPr lvl="1"/>
+            <a:r>
+              <a:rPr lang="cs-CZ" dirty="0"/>
+              <a:t>P</a:t>
+            </a:r>
+            <a:r>
+              <a:rPr lang="en-US" dirty="0" err="1"/>
+              <a:t>arsed</a:t>
+            </a:r>
+            <a:r>
+              <a:rPr lang="en-US" dirty="0"/>
+              <a:t> the SQLite data</a:t>
+            </a:r>
+          </a:p>
+          <a:p>
+            <a:pPr lvl="1"/>
+            <a:r>
+              <a:rPr lang="cs-CZ" dirty="0"/>
+              <a:t>G</a:t>
+            </a:r>
+            <a:r>
+              <a:rPr lang="en-US" dirty="0" err="1"/>
+              <a:t>enerated</a:t>
+            </a:r>
+            <a:r>
+              <a:rPr lang="en-US" dirty="0"/>
+              <a:t> SQL Server-compatible INSERT scripts for each entity</a:t>
+            </a:r>
+          </a:p>
+          <a:p>
+            <a:pPr lvl="1"/>
+            <a:r>
+              <a:rPr lang="cs-CZ" dirty="0"/>
+              <a:t>H</a:t>
+            </a:r>
+            <a:r>
+              <a:rPr lang="en-US" dirty="0" err="1"/>
+              <a:t>andled</a:t>
+            </a:r>
+            <a:r>
+              <a:rPr lang="en-US" dirty="0"/>
+              <a:t> </a:t>
+            </a:r>
+            <a:r>
+              <a:rPr lang="en-US" b="1" dirty="0"/>
+              <a:t>type conversion</a:t>
+            </a:r>
+            <a:r>
+              <a:rPr lang="en-US" dirty="0"/>
+              <a:t>, scientific notation, FK ordering, and </a:t>
+            </a:r>
+            <a:r>
+              <a:rPr lang="en-US" b="1" dirty="0"/>
+              <a:t>data validation</a:t>
+            </a:r>
+          </a:p>
+          <a:p>
+            <a:r>
+              <a:rPr lang="en-US" dirty="0"/>
+              <a:t>Scripts executed in SQL Server Management Studio to create and populate the database on </a:t>
+            </a:r>
+            <a:r>
+              <a:rPr lang="en-US" b="1" dirty="0"/>
+              <a:t>local SQL Server</a:t>
+            </a:r>
+          </a:p>
+          <a:p>
+            <a:r>
+              <a:rPr lang="en-US" dirty="0"/>
+              <a:t>Database exported as a </a:t>
+            </a:r>
+            <a:r>
+              <a:rPr lang="en-US" b="1" dirty="0"/>
+              <a:t>.</a:t>
+            </a:r>
+            <a:r>
+              <a:rPr lang="en-US" b="1" dirty="0" err="1"/>
+              <a:t>bacpac</a:t>
+            </a:r>
+            <a:r>
+              <a:rPr lang="en-US" dirty="0"/>
+              <a:t> file and uploaded to </a:t>
+            </a:r>
+            <a:r>
+              <a:rPr lang="en-US" b="1" dirty="0"/>
+              <a:t>Azure SQL</a:t>
+            </a:r>
+            <a:r>
+              <a:rPr lang="en-US" dirty="0"/>
+              <a:t> for team access</a:t>
+            </a:r>
+          </a:p>
+          <a:p>
+            <a:r>
+              <a:rPr lang="en-US" dirty="0"/>
+              <a:t>SQL Server database schema </a:t>
+            </a:r>
+            <a:r>
+              <a:rPr lang="cs-CZ" b="1" dirty="0" err="1"/>
+              <a:t>verified</a:t>
+            </a:r>
+            <a:r>
+              <a:rPr lang="en-US" dirty="0"/>
+              <a:t> via an SQL script</a:t>
+            </a:r>
+            <a:endParaRPr lang="cs-CZ" dirty="0"/>
+          </a:p>
+          <a:p>
+            <a:pPr lvl="1"/>
+            <a:r>
+              <a:rPr lang="cs-CZ" dirty="0" err="1"/>
+              <a:t>Verified</a:t>
+            </a:r>
+            <a:r>
+              <a:rPr lang="cs-CZ" dirty="0"/>
+              <a:t> data profile and </a:t>
+            </a:r>
+            <a:r>
+              <a:rPr lang="cs-CZ" dirty="0" err="1"/>
+              <a:t>types</a:t>
+            </a:r>
+            <a:r>
+              <a:rPr lang="cs-CZ" dirty="0"/>
+              <a:t> (sanity </a:t>
+            </a:r>
+            <a:r>
+              <a:rPr lang="cs-CZ" dirty="0" err="1"/>
+              <a:t>check</a:t>
+            </a:r>
+            <a:r>
+              <a:rPr lang="cs-CZ" dirty="0"/>
+              <a:t>)</a:t>
+            </a:r>
+          </a:p>
+          <a:p>
+            <a:pPr lvl="1"/>
+            <a:r>
+              <a:rPr lang="cs-CZ" dirty="0" err="1"/>
+              <a:t>Compared</a:t>
+            </a:r>
+            <a:r>
+              <a:rPr lang="cs-CZ" dirty="0"/>
+              <a:t> </a:t>
+            </a:r>
+            <a:r>
+              <a:rPr lang="cs-CZ" dirty="0" err="1"/>
+              <a:t>the</a:t>
+            </a:r>
+            <a:r>
+              <a:rPr lang="cs-CZ" dirty="0"/>
+              <a:t> </a:t>
+            </a:r>
+            <a:r>
+              <a:rPr lang="cs-CZ" dirty="0" err="1"/>
+              <a:t>result</a:t>
+            </a:r>
+            <a:r>
+              <a:rPr lang="cs-CZ" dirty="0"/>
+              <a:t> to </a:t>
+            </a:r>
+            <a:r>
+              <a:rPr lang="cs-CZ" dirty="0" err="1"/>
+              <a:t>an</a:t>
+            </a:r>
+            <a:r>
+              <a:rPr lang="cs-CZ" dirty="0"/>
+              <a:t> </a:t>
+            </a:r>
+            <a:r>
+              <a:rPr lang="cs-CZ" dirty="0" err="1"/>
+              <a:t>SQLite</a:t>
+            </a:r>
+            <a:r>
+              <a:rPr lang="cs-CZ" dirty="0"/>
+              <a:t> script ran on </a:t>
+            </a:r>
+            <a:r>
+              <a:rPr lang="cs-CZ" dirty="0" err="1"/>
+              <a:t>the</a:t>
+            </a:r>
+            <a:r>
+              <a:rPr lang="cs-CZ" dirty="0"/>
+              <a:t> </a:t>
+            </a:r>
+            <a:r>
+              <a:rPr lang="cs-CZ" dirty="0" err="1"/>
+              <a:t>original</a:t>
+            </a:r>
+            <a:r>
+              <a:rPr lang="cs-CZ" dirty="0"/>
+              <a:t> </a:t>
+            </a:r>
+            <a:r>
+              <a:rPr lang="cs-CZ" dirty="0" err="1"/>
+              <a:t>SQLite</a:t>
+            </a:r>
+            <a:r>
+              <a:rPr lang="cs-CZ" dirty="0"/>
+              <a:t> database</a:t>
+            </a:r>
+            <a:endParaRPr lang="en-US" dirty="0"/>
+          </a:p>
+        </p:txBody>
+      </p:sp>
+    </p:spTree>
+    <p:extLst>
+      <p:ext uri="{BB962C8B-B14F-4D97-AF65-F5344CB8AC3E}">
+        <p14:creationId xmlns:p14="http://schemas.microsoft.com/office/powerpoint/2010/main" val="3352467750"/>
+      </p:ext>
+    </p:extLst>
+  </p:cSld>
+  <p:clrMapOvr>
+    <a:masterClrMapping/>
+  </p:clrMapOvr>
+</p:sld>
+</file>
+
+<file path=ppt/slides/slide4.xml><?xml version="1.0" encoding="utf-8"?>
 <p:sld xmlns:a="http://schemas.openxmlformats.org/drawingml/2006/main" xmlns:r="http://schemas.openxmlformats.org/officeDocument/2006/relationships" xmlns:p="http://schemas.openxmlformats.org/presentationml/2006/main">
   <p:cSld>
     <p:bg>
@@ -24891,7 +26496,7 @@
 </p:sld>
 </file>
 
-<file path=ppt/slides/slide4.xml><?xml version="1.0" encoding="utf-8"?>
+<file path=ppt/slides/slide5.xml><?xml version="1.0" encoding="utf-8"?>
 <p:sld xmlns:a="http://schemas.openxmlformats.org/drawingml/2006/main" xmlns:r="http://schemas.openxmlformats.org/officeDocument/2006/relationships" xmlns:p="http://schemas.openxmlformats.org/presentationml/2006/main">
   <p:cSld>
     <p:spTree>
@@ -24977,7 +26582,7 @@
 </p:sld>
 </file>
 
-<file path=ppt/slides/slide5.xml><?xml version="1.0" encoding="utf-8"?>
+<file path=ppt/slides/slide6.xml><?xml version="1.0" encoding="utf-8"?>
 <p:sld xmlns:a="http://schemas.openxmlformats.org/drawingml/2006/main" xmlns:r="http://schemas.openxmlformats.org/officeDocument/2006/relationships" xmlns:p="http://schemas.openxmlformats.org/presentationml/2006/main">
   <p:cSld>
     <p:spTree>
@@ -25017,7 +26622,7 @@
           <a:p>
             <a:r>
               <a:rPr lang="en-US" dirty="0"/>
-              <a:t>Revenue Trends &amp; Payment Methods</a:t>
+              <a:t>Revenue Trends</a:t>
             </a:r>
           </a:p>
         </p:txBody>
@@ -25045,7 +26650,7 @@
           <a:p>
             <a:r>
               <a:rPr lang="en-US" dirty="0"/>
-              <a:t>Q1</a:t>
+              <a:t>Q1 (+ View)</a:t>
             </a:r>
           </a:p>
         </p:txBody>
@@ -25072,44 +26677,140 @@
           <a:lstStyle/>
           <a:p>
             <a:r>
-              <a:rPr lang="en-US" dirty="0"/>
-              <a:t>Orders grew 9x from January 2017 (~750) to January 2018 (~7,069)</a:t>
+              <a:rPr lang="en-US" b="1" dirty="0"/>
+              <a:t>Revenue grew 9x</a:t>
             </a:r>
-          </a:p>
-          <a:p>
             <a:r>
               <a:rPr lang="en-US" dirty="0"/>
-              <a:t>Nov 2017 revenue spike: R$1.15M</a:t>
+              <a:t> from January 2017</a:t>
             </a:r>
             <a:br>
               <a:rPr lang="en-US" dirty="0"/>
             </a:br>
             <a:r>
               <a:rPr lang="en-US" dirty="0"/>
-              <a:t>— Black Friday effect</a:t>
-            </a:r>
-          </a:p>
-          <a:p>
-            <a:r>
-              <a:rPr lang="en-US" dirty="0"/>
-              <a:t>Dataset ends Aug 2018</a:t>
+              <a:t>to peak in November 2017</a:t>
             </a:r>
             <a:br>
               <a:rPr lang="en-US" dirty="0"/>
             </a:br>
             <a:r>
               <a:rPr lang="en-US" dirty="0"/>
-              <a:t>— not a revenue decline</a:t>
+              <a:t>— potential seasonality</a:t>
+            </a:r>
+            <a:br>
+              <a:rPr lang="en-US" dirty="0"/>
+            </a:br>
+            <a:r>
+              <a:rPr lang="en-US" dirty="0"/>
+              <a:t>(Black Friday effect)</a:t>
+            </a:r>
+          </a:p>
+          <a:p>
+            <a:r>
+              <a:rPr lang="en-US" b="1" dirty="0"/>
+              <a:t>Average</a:t>
+            </a:r>
+            <a:r>
+              <a:rPr lang="en-US" dirty="0"/>
+              <a:t> monthly growth was 15%</a:t>
+            </a:r>
+          </a:p>
+          <a:p>
+            <a:r>
+              <a:rPr lang="en-US" dirty="0"/>
+              <a:t>Revenue </a:t>
+            </a:r>
+            <a:r>
+              <a:rPr lang="en-US" b="1" dirty="0"/>
+              <a:t>plateaued</a:t>
+            </a:r>
+            <a:r>
+              <a:rPr lang="en-US" dirty="0"/>
+              <a:t> in 2018 around R$1M</a:t>
             </a:r>
           </a:p>
         </p:txBody>
       </p:sp>
+      <p:pic>
+        <p:nvPicPr>
+          <p:cNvPr id="12" name="Content Placeholder 11">
+            <a:extLst>
+              <a:ext uri="{FF2B5EF4-FFF2-40B4-BE49-F238E27FC236}">
+                <a16:creationId xmlns:a16="http://schemas.microsoft.com/office/drawing/2014/main" id="{0B2F043B-34CA-9F4F-EFA4-BDF09EBAFF68}"/>
+              </a:ext>
+            </a:extLst>
+          </p:cNvPr>
+          <p:cNvPicPr>
+            <a:picLocks noGrp="1" noChangeAspect="1"/>
+          </p:cNvPicPr>
+          <p:nvPr>
+            <p:ph sz="quarter" idx="4"/>
+          </p:nvPr>
+        </p:nvPicPr>
+        <p:blipFill>
+          <a:blip r:embed="rId2">
+            <a:extLst>
+              <a:ext uri="{28A0092B-C50C-407E-A947-70E740481C1C}">
+                <a14:useLocalDpi xmlns:a14="http://schemas.microsoft.com/office/drawing/2010/main" val="0"/>
+              </a:ext>
+            </a:extLst>
+          </a:blip>
+          <a:srcRect/>
+          <a:stretch/>
+        </p:blipFill>
+        <p:spPr>
+          <a:xfrm>
+            <a:off x="5614315" y="2591116"/>
+            <a:ext cx="5553557" cy="3262792"/>
+          </a:xfrm>
+          <a:prstGeom prst="rect">
+            <a:avLst/>
+          </a:prstGeom>
+        </p:spPr>
+      </p:pic>
+    </p:spTree>
+    <p:extLst>
+      <p:ext uri="{BB962C8B-B14F-4D97-AF65-F5344CB8AC3E}">
+        <p14:creationId xmlns:p14="http://schemas.microsoft.com/office/powerpoint/2010/main" val="1094190350"/>
+      </p:ext>
+    </p:extLst>
+  </p:cSld>
+  <p:clrMapOvr>
+    <a:masterClrMapping/>
+  </p:clrMapOvr>
+</p:sld>
+</file>
+
+<file path=ppt/slides/slide7.xml><?xml version="1.0" encoding="utf-8"?>
+<p:sld xmlns:a="http://schemas.openxmlformats.org/drawingml/2006/main" xmlns:r="http://schemas.openxmlformats.org/officeDocument/2006/relationships" xmlns:p="http://schemas.openxmlformats.org/presentationml/2006/main">
+  <p:cSld>
+    <p:spTree>
+      <p:nvGrpSpPr>
+        <p:cNvPr id="1" name="">
+          <a:extLst>
+            <a:ext uri="{FF2B5EF4-FFF2-40B4-BE49-F238E27FC236}">
+              <a16:creationId xmlns:a16="http://schemas.microsoft.com/office/drawing/2014/main" id="{1CDF7E7E-E86F-BF34-4266-26DE5F24A3F5}"/>
+            </a:ext>
+          </a:extLst>
+        </p:cNvPr>
+        <p:cNvGrpSpPr/>
+        <p:nvPr/>
+      </p:nvGrpSpPr>
+      <p:grpSpPr>
+        <a:xfrm>
+          <a:off x="0" y="0"/>
+          <a:ext cx="0" cy="0"/>
+          <a:chOff x="0" y="0"/>
+          <a:chExt cx="0" cy="0"/>
+        </a:xfrm>
+      </p:grpSpPr>
       <p:sp>
         <p:nvSpPr>
-          <p:cNvPr id="10" name="Text Placeholder 9">
+          <p:cNvPr id="7" name="Title 6">
             <a:extLst>
               <a:ext uri="{FF2B5EF4-FFF2-40B4-BE49-F238E27FC236}">
-                <a16:creationId xmlns:a16="http://schemas.microsoft.com/office/drawing/2014/main" id="{E88F7E96-7FEC-1CBA-B922-1799F1C24513}"/>
+                <a16:creationId xmlns:a16="http://schemas.microsoft.com/office/drawing/2014/main" id="{B218C80C-155D-F089-E84F-73A4E80E3568}"/>
               </a:ext>
             </a:extLst>
           </p:cNvPr>
@@ -25117,7 +26818,35 @@
             <a:spLocks noGrp="1"/>
           </p:cNvSpPr>
           <p:nvPr>
-            <p:ph type="body" sz="quarter" idx="3"/>
+            <p:ph type="title"/>
+          </p:nvPr>
+        </p:nvSpPr>
+        <p:spPr/>
+        <p:txBody>
+          <a:bodyPr/>
+          <a:lstStyle/>
+          <a:p>
+            <a:r>
+              <a:rPr lang="en-US" dirty="0"/>
+              <a:t>Payment Methods</a:t>
+            </a:r>
+          </a:p>
+        </p:txBody>
+      </p:sp>
+      <p:sp>
+        <p:nvSpPr>
+          <p:cNvPr id="8" name="Text Placeholder 7">
+            <a:extLst>
+              <a:ext uri="{FF2B5EF4-FFF2-40B4-BE49-F238E27FC236}">
+                <a16:creationId xmlns:a16="http://schemas.microsoft.com/office/drawing/2014/main" id="{F551A200-32D5-D819-B163-F3710DDDC013}"/>
+              </a:ext>
+            </a:extLst>
+          </p:cNvPr>
+          <p:cNvSpPr>
+            <a:spLocks noGrp="1"/>
+          </p:cNvSpPr>
+          <p:nvPr>
+            <p:ph type="body" idx="1"/>
           </p:nvPr>
         </p:nvSpPr>
         <p:spPr/>
@@ -25134,10 +26863,10 @@
       </p:sp>
       <p:sp>
         <p:nvSpPr>
-          <p:cNvPr id="11" name="Content Placeholder 10">
+          <p:cNvPr id="9" name="Content Placeholder 8">
             <a:extLst>
               <a:ext uri="{FF2B5EF4-FFF2-40B4-BE49-F238E27FC236}">
-                <a16:creationId xmlns:a16="http://schemas.microsoft.com/office/drawing/2014/main" id="{883DF136-3D88-B9A9-D241-011616964AF1}"/>
+                <a16:creationId xmlns:a16="http://schemas.microsoft.com/office/drawing/2014/main" id="{46929EB6-3647-FFAC-71AD-4ABFBB35A46C}"/>
               </a:ext>
             </a:extLst>
           </p:cNvPr>
@@ -25145,7 +26874,7 @@
             <a:spLocks noGrp="1"/>
           </p:cNvSpPr>
           <p:nvPr>
-            <p:ph sz="quarter" idx="4"/>
+            <p:ph sz="half" idx="2"/>
           </p:nvPr>
         </p:nvSpPr>
         <p:spPr/>
@@ -25154,32 +26883,81 @@
           <a:lstStyle/>
           <a:p>
             <a:r>
+              <a:rPr lang="en-US" b="1" dirty="0"/>
+              <a:t>Credit cards</a:t>
+            </a:r>
+            <a:r>
               <a:rPr lang="en-US" dirty="0"/>
-              <a:t>Credit card dominates — 76,505 orders, avg 3.5 installments</a:t>
+              <a:t> dominate</a:t>
+            </a:r>
+            <a:br>
+              <a:rPr lang="en-US" dirty="0"/>
+            </a:br>
+            <a:r>
+              <a:rPr lang="en-US" dirty="0"/>
+              <a:t>— CC purchases split to 3.5 installments on average, confirms that installment culture is important in Brazilian e-commerce</a:t>
             </a:r>
           </a:p>
           <a:p>
             <a:r>
-              <a:rPr lang="en-US" dirty="0" err="1"/>
+              <a:rPr lang="en-US" b="1" dirty="0" err="1"/>
               <a:t>Boleto</a:t>
             </a:r>
             <a:r>
               <a:rPr lang="en-US" dirty="0"/>
-              <a:t> (bank slip) second: 19,784 orders — no card required</a:t>
+              <a:t> (bank slip) second</a:t>
             </a:r>
-          </a:p>
-          <a:p>
+            <a:br>
+              <a:rPr lang="en-US" dirty="0"/>
+            </a:br>
             <a:r>
               <a:rPr lang="en-US" dirty="0"/>
-              <a:t>Installment culture is central to Brazilian e-commerce</a:t>
+              <a:t>— no card required</a:t>
             </a:r>
           </a:p>
         </p:txBody>
       </p:sp>
+      <p:pic>
+        <p:nvPicPr>
+          <p:cNvPr id="12" name="Content Placeholder 11">
+            <a:extLst>
+              <a:ext uri="{FF2B5EF4-FFF2-40B4-BE49-F238E27FC236}">
+                <a16:creationId xmlns:a16="http://schemas.microsoft.com/office/drawing/2014/main" id="{3323EC8F-035A-2D2E-C23B-14D40A5CB204}"/>
+              </a:ext>
+            </a:extLst>
+          </p:cNvPr>
+          <p:cNvPicPr>
+            <a:picLocks noGrp="1" noChangeAspect="1"/>
+          </p:cNvPicPr>
+          <p:nvPr>
+            <p:ph sz="quarter" idx="4"/>
+          </p:nvPr>
+        </p:nvPicPr>
+        <p:blipFill>
+          <a:blip r:embed="rId2">
+            <a:extLst>
+              <a:ext uri="{28A0092B-C50C-407E-A947-70E740481C1C}">
+                <a14:useLocalDpi xmlns:a14="http://schemas.microsoft.com/office/drawing/2010/main" val="0"/>
+              </a:ext>
+            </a:extLst>
+          </a:blip>
+          <a:srcRect/>
+          <a:stretch/>
+        </p:blipFill>
+        <p:spPr>
+          <a:xfrm>
+            <a:off x="5884164" y="2591116"/>
+            <a:ext cx="5550408" cy="3211439"/>
+          </a:xfrm>
+          <a:prstGeom prst="rect">
+            <a:avLst/>
+          </a:prstGeom>
+        </p:spPr>
+      </p:pic>
     </p:spTree>
     <p:extLst>
       <p:ext uri="{BB962C8B-B14F-4D97-AF65-F5344CB8AC3E}">
-        <p14:creationId xmlns:p14="http://schemas.microsoft.com/office/powerpoint/2010/main" val="1094190350"/>
+        <p14:creationId xmlns:p14="http://schemas.microsoft.com/office/powerpoint/2010/main" val="1662100909"/>
       </p:ext>
     </p:extLst>
   </p:cSld>
@@ -25189,7 +26967,7 @@
 </p:sld>
 </file>
 
-<file path=ppt/slides/slide6.xml><?xml version="1.0" encoding="utf-8"?>
+<file path=ppt/slides/slide8.xml><?xml version="1.0" encoding="utf-8"?>
 <p:sld xmlns:a="http://schemas.openxmlformats.org/drawingml/2006/main" xmlns:r="http://schemas.openxmlformats.org/officeDocument/2006/relationships" xmlns:p="http://schemas.openxmlformats.org/presentationml/2006/main">
   <p:cSld>
     <p:spTree>
@@ -25229,7 +27007,7 @@
           <a:p>
             <a:r>
               <a:rPr lang="en-US" dirty="0"/>
-              <a:t>Order Value by State &amp; Top Categories</a:t>
+              <a:t>Order Value by State</a:t>
             </a:r>
           </a:p>
         </p:txBody>
@@ -25285,13 +27063,25 @@
           <a:p>
             <a:r>
               <a:rPr lang="en-US" dirty="0"/>
-              <a:t>Top 10 highest avg order value are all North/Northeast states</a:t>
+              <a:t>Top 10 </a:t>
+            </a:r>
+            <a:r>
+              <a:rPr lang="en-US" b="1" dirty="0"/>
+              <a:t>highest avg order</a:t>
+            </a:r>
+            <a:r>
+              <a:rPr lang="en-US" dirty="0"/>
+              <a:t> value are all North/Northeast states</a:t>
             </a:r>
           </a:p>
           <a:p>
             <a:r>
+              <a:rPr lang="en-US" b="1" dirty="0"/>
+              <a:t>Paraíba</a:t>
+            </a:r>
+            <a:r>
               <a:rPr lang="en-US" dirty="0"/>
-              <a:t>Paraíba highest: avg product</a:t>
+              <a:t> highest: average product value</a:t>
             </a:r>
             <a:br>
               <a:rPr lang="en-US" dirty="0"/>
@@ -25316,88 +27106,44 @@
           </a:p>
         </p:txBody>
       </p:sp>
-      <p:sp>
-        <p:nvSpPr>
-          <p:cNvPr id="5" name="Text Placeholder 4">
+      <p:pic>
+        <p:nvPicPr>
+          <p:cNvPr id="12" name="Content Placeholder 11">
             <a:extLst>
               <a:ext uri="{FF2B5EF4-FFF2-40B4-BE49-F238E27FC236}">
-                <a16:creationId xmlns:a16="http://schemas.microsoft.com/office/drawing/2014/main" id="{3A56FE17-6551-BC43-8051-A9768FD2BEF9}"/>
+                <a16:creationId xmlns:a16="http://schemas.microsoft.com/office/drawing/2014/main" id="{474A8FA5-08AC-5AD7-B425-4F3967258738}"/>
               </a:ext>
             </a:extLst>
           </p:cNvPr>
-          <p:cNvSpPr>
-            <a:spLocks noGrp="1"/>
-          </p:cNvSpPr>
-          <p:nvPr>
-            <p:ph type="body" sz="quarter" idx="3"/>
-          </p:nvPr>
-        </p:nvSpPr>
-        <p:spPr/>
-        <p:txBody>
-          <a:bodyPr/>
-          <a:lstStyle/>
-          <a:p>
-            <a:r>
-              <a:rPr lang="en-US" dirty="0"/>
-              <a:t>Q4</a:t>
-            </a:r>
-          </a:p>
-        </p:txBody>
-      </p:sp>
-      <p:sp>
-        <p:nvSpPr>
-          <p:cNvPr id="6" name="Content Placeholder 5">
-            <a:extLst>
-              <a:ext uri="{FF2B5EF4-FFF2-40B4-BE49-F238E27FC236}">
-                <a16:creationId xmlns:a16="http://schemas.microsoft.com/office/drawing/2014/main" id="{6E53D4E1-B327-658E-E128-6C1D5838E760}"/>
-              </a:ext>
-            </a:extLst>
-          </p:cNvPr>
-          <p:cNvSpPr>
-            <a:spLocks noGrp="1"/>
-          </p:cNvSpPr>
+          <p:cNvPicPr>
+            <a:picLocks noGrp="1" noChangeAspect="1"/>
+          </p:cNvPicPr>
           <p:nvPr>
             <p:ph sz="quarter" idx="4"/>
           </p:nvPr>
-        </p:nvSpPr>
-        <p:spPr/>
-        <p:txBody>
-          <a:bodyPr/>
-          <a:lstStyle/>
-          <a:p>
-            <a:r>
-              <a:rPr lang="en-US" dirty="0"/>
-              <a:t>Health &amp; beauty is #1 category by revenue: R$1.44M</a:t>
-            </a:r>
-          </a:p>
-          <a:p>
-            <a:r>
-              <a:rPr lang="en-US" dirty="0"/>
-              <a:t>Watches &amp; gifts #2</a:t>
-            </a:r>
-            <a:br>
-              <a:rPr lang="en-US" dirty="0"/>
-            </a:br>
-            <a:r>
-              <a:rPr lang="en-US" dirty="0"/>
-              <a:t>Bed/bath/table #3</a:t>
-            </a:r>
-            <a:br>
-              <a:rPr lang="en-US" dirty="0"/>
-            </a:br>
-            <a:r>
-              <a:rPr lang="en-US" dirty="0"/>
-              <a:t>— lifestyle over electronics</a:t>
-            </a:r>
-          </a:p>
-          <a:p>
-            <a:r>
-              <a:rPr lang="en-US" dirty="0"/>
-              <a:t>No single tech category in the top 10</a:t>
-            </a:r>
-          </a:p>
-        </p:txBody>
-      </p:sp>
+        </p:nvPicPr>
+        <p:blipFill>
+          <a:blip r:embed="rId2">
+            <a:extLst>
+              <a:ext uri="{28A0092B-C50C-407E-A947-70E740481C1C}">
+                <a14:useLocalDpi xmlns:a14="http://schemas.microsoft.com/office/drawing/2010/main" val="0"/>
+              </a:ext>
+            </a:extLst>
+          </a:blip>
+          <a:stretch>
+            <a:fillRect/>
+          </a:stretch>
+        </p:blipFill>
+        <p:spPr>
+          <a:xfrm>
+            <a:off x="5597188" y="548640"/>
+            <a:ext cx="6480512" cy="6080173"/>
+          </a:xfrm>
+          <a:prstGeom prst="rect">
+            <a:avLst/>
+          </a:prstGeom>
+        </p:spPr>
+      </p:pic>
     </p:spTree>
     <p:extLst>
       <p:ext uri="{BB962C8B-B14F-4D97-AF65-F5344CB8AC3E}">
@@ -25411,12 +27157,18 @@
 </p:sld>
 </file>
 
-<file path=ppt/slides/slide7.xml><?xml version="1.0" encoding="utf-8"?>
+<file path=ppt/slides/slide9.xml><?xml version="1.0" encoding="utf-8"?>
 <p:sld xmlns:a="http://schemas.openxmlformats.org/drawingml/2006/main" xmlns:r="http://schemas.openxmlformats.org/officeDocument/2006/relationships" xmlns:p="http://schemas.openxmlformats.org/presentationml/2006/main">
   <p:cSld>
     <p:spTree>
       <p:nvGrpSpPr>
-        <p:cNvPr id="1" name=""/>
+        <p:cNvPr id="1" name="">
+          <a:extLst>
+            <a:ext uri="{FF2B5EF4-FFF2-40B4-BE49-F238E27FC236}">
+              <a16:creationId xmlns:a16="http://schemas.microsoft.com/office/drawing/2014/main" id="{BE46EF7D-C4D3-1886-3EFD-250D00DC8260}"/>
+            </a:ext>
+          </a:extLst>
+        </p:cNvPr>
         <p:cNvGrpSpPr/>
         <p:nvPr/>
       </p:nvGrpSpPr>
@@ -25430,10 +27182,10 @@
       </p:grpSpPr>
       <p:sp>
         <p:nvSpPr>
-          <p:cNvPr id="7" name="Title 6">
+          <p:cNvPr id="2" name="Title 1">
             <a:extLst>
               <a:ext uri="{FF2B5EF4-FFF2-40B4-BE49-F238E27FC236}">
-                <a16:creationId xmlns:a16="http://schemas.microsoft.com/office/drawing/2014/main" id="{5BD0FE1D-EE1D-CBA0-440A-FC5AF9D86BAB}"/>
+                <a16:creationId xmlns:a16="http://schemas.microsoft.com/office/drawing/2014/main" id="{3187A426-DB27-7205-36CC-082B1FD1B064}"/>
               </a:ext>
             </a:extLst>
           </p:cNvPr>
@@ -25451,17 +27203,17 @@
           <a:p>
             <a:r>
               <a:rPr lang="en-US" dirty="0"/>
-              <a:t>Customer &amp; Delivery Behavior</a:t>
+              <a:t>Top 10 Categories by revenue</a:t>
             </a:r>
           </a:p>
         </p:txBody>
       </p:sp>
       <p:sp>
         <p:nvSpPr>
-          <p:cNvPr id="8" name="Text Placeholder 7">
+          <p:cNvPr id="3" name="Text Placeholder 2">
             <a:extLst>
               <a:ext uri="{FF2B5EF4-FFF2-40B4-BE49-F238E27FC236}">
-                <a16:creationId xmlns:a16="http://schemas.microsoft.com/office/drawing/2014/main" id="{B732DF04-1DE9-5BF9-6277-EF7309B44354}"/>
+                <a16:creationId xmlns:a16="http://schemas.microsoft.com/office/drawing/2014/main" id="{BE484BA7-BE6A-AD2F-4130-D5561A2CF76D}"/>
               </a:ext>
             </a:extLst>
           </p:cNvPr>
@@ -25479,93 +27231,7 @@
           <a:p>
             <a:r>
               <a:rPr lang="en-US" dirty="0"/>
-              <a:t>Michael Amaya | Q5–Q8</a:t>
-            </a:r>
-          </a:p>
-        </p:txBody>
-      </p:sp>
-    </p:spTree>
-    <p:extLst>
-      <p:ext uri="{BB962C8B-B14F-4D97-AF65-F5344CB8AC3E}">
-        <p14:creationId xmlns:p14="http://schemas.microsoft.com/office/powerpoint/2010/main" val="2306582258"/>
-      </p:ext>
-    </p:extLst>
-  </p:cSld>
-  <p:clrMapOvr>
-    <a:masterClrMapping/>
-  </p:clrMapOvr>
-</p:sld>
-</file>
-
-<file path=ppt/slides/slide8.xml><?xml version="1.0" encoding="utf-8"?>
-<p:sld xmlns:a="http://schemas.openxmlformats.org/drawingml/2006/main" xmlns:r="http://schemas.openxmlformats.org/officeDocument/2006/relationships" xmlns:p="http://schemas.openxmlformats.org/presentationml/2006/main">
-  <p:cSld>
-    <p:spTree>
-      <p:nvGrpSpPr>
-        <p:cNvPr id="1" name=""/>
-        <p:cNvGrpSpPr/>
-        <p:nvPr/>
-      </p:nvGrpSpPr>
-      <p:grpSpPr>
-        <a:xfrm>
-          <a:off x="0" y="0"/>
-          <a:ext cx="0" cy="0"/>
-          <a:chOff x="0" y="0"/>
-          <a:chExt cx="0" cy="0"/>
-        </a:xfrm>
-      </p:grpSpPr>
-      <p:sp>
-        <p:nvSpPr>
-          <p:cNvPr id="2" name="Title 1">
-            <a:extLst>
-              <a:ext uri="{FF2B5EF4-FFF2-40B4-BE49-F238E27FC236}">
-                <a16:creationId xmlns:a16="http://schemas.microsoft.com/office/drawing/2014/main" id="{A7D68A88-CD02-E230-F679-81946D1CFA58}"/>
-              </a:ext>
-            </a:extLst>
-          </p:cNvPr>
-          <p:cNvSpPr>
-            <a:spLocks noGrp="1"/>
-          </p:cNvSpPr>
-          <p:nvPr>
-            <p:ph type="title"/>
-          </p:nvPr>
-        </p:nvSpPr>
-        <p:spPr/>
-        <p:txBody>
-          <a:bodyPr/>
-          <a:lstStyle/>
-          <a:p>
-            <a:r>
-              <a:rPr lang="en-US" dirty="0"/>
-              <a:t>Delivery Time &amp; Customer Reviews</a:t>
-            </a:r>
-          </a:p>
-        </p:txBody>
-      </p:sp>
-      <p:sp>
-        <p:nvSpPr>
-          <p:cNvPr id="3" name="Text Placeholder 2">
-            <a:extLst>
-              <a:ext uri="{FF2B5EF4-FFF2-40B4-BE49-F238E27FC236}">
-                <a16:creationId xmlns:a16="http://schemas.microsoft.com/office/drawing/2014/main" id="{3B5E2797-167C-8E8B-B485-E71790C6E69C}"/>
-              </a:ext>
-            </a:extLst>
-          </p:cNvPr>
-          <p:cNvSpPr>
-            <a:spLocks noGrp="1"/>
-          </p:cNvSpPr>
-          <p:nvPr>
-            <p:ph type="body" idx="1"/>
-          </p:nvPr>
-        </p:nvSpPr>
-        <p:spPr/>
-        <p:txBody>
-          <a:bodyPr/>
-          <a:lstStyle/>
-          <a:p>
-            <a:r>
-              <a:rPr lang="en-US" dirty="0"/>
-              <a:t>Q5</a:t>
+              <a:t>Q4</a:t>
             </a:r>
           </a:p>
         </p:txBody>
@@ -25575,7 +27241,7 @@
           <p:cNvPr id="4" name="Content Placeholder 3">
             <a:extLst>
               <a:ext uri="{FF2B5EF4-FFF2-40B4-BE49-F238E27FC236}">
-                <a16:creationId xmlns:a16="http://schemas.microsoft.com/office/drawing/2014/main" id="{E72F4CE0-5F18-E6DB-A60B-95D50722AD46}"/>
+                <a16:creationId xmlns:a16="http://schemas.microsoft.com/office/drawing/2014/main" id="{8E24BD4E-FA52-85CE-FEEF-1C194D4384F3}"/>
               </a:ext>
             </a:extLst>
           </p:cNvPr>
@@ -25592,242 +27258,89 @@
           <a:lstStyle/>
           <a:p>
             <a:r>
+              <a:rPr lang="en-US" b="1" dirty="0"/>
+              <a:t>Health &amp; beauty</a:t>
+            </a:r>
+            <a:br>
+              <a:rPr lang="en-US" b="1" dirty="0"/>
+            </a:br>
+            <a:r>
               <a:rPr lang="en-US" dirty="0"/>
-              <a:t>TODO</a:t>
+              <a:t>is #1 category</a:t>
+            </a:r>
+            <a:br>
+              <a:rPr lang="en-US" dirty="0"/>
+            </a:br>
+            <a:r>
+              <a:rPr lang="en-US" dirty="0"/>
+              <a:t>by revenue: R$1.44M</a:t>
+            </a:r>
+          </a:p>
+          <a:p>
+            <a:r>
+              <a:rPr lang="en-US" b="1" dirty="0"/>
+              <a:t>Watches &amp; gifts</a:t>
+            </a:r>
+            <a:r>
+              <a:rPr lang="en-US" dirty="0"/>
+              <a:t> #2</a:t>
+            </a:r>
+            <a:br>
+              <a:rPr lang="en-US" dirty="0"/>
+            </a:br>
+            <a:r>
+              <a:rPr lang="en-US" b="1" dirty="0"/>
+              <a:t>Bed/bath/table</a:t>
+            </a:r>
+            <a:r>
+              <a:rPr lang="en-US" dirty="0"/>
+              <a:t> #3</a:t>
+            </a:r>
+            <a:br>
+              <a:rPr lang="en-US" dirty="0"/>
+            </a:br>
+            <a:r>
+              <a:rPr lang="en-US" dirty="0"/>
+              <a:t>— lifestyle over electronics</a:t>
             </a:r>
           </a:p>
         </p:txBody>
       </p:sp>
-      <p:sp>
-        <p:nvSpPr>
-          <p:cNvPr id="5" name="Text Placeholder 4">
+      <p:graphicFrame>
+        <p:nvGraphicFramePr>
+          <p:cNvPr id="13" name="Content Placeholder 12">
             <a:extLst>
               <a:ext uri="{FF2B5EF4-FFF2-40B4-BE49-F238E27FC236}">
-                <a16:creationId xmlns:a16="http://schemas.microsoft.com/office/drawing/2014/main" id="{5F0F5418-56A8-AEE0-C231-11278121AA9D}"/>
+                <a16:creationId xmlns:a16="http://schemas.microsoft.com/office/drawing/2014/main" id="{22898495-DC58-D4FC-1810-A0C7A14816AE}"/>
               </a:ext>
             </a:extLst>
           </p:cNvPr>
-          <p:cNvSpPr>
-            <a:spLocks noGrp="1"/>
-          </p:cNvSpPr>
-          <p:nvPr>
-            <p:ph type="body" sz="quarter" idx="3"/>
-          </p:nvPr>
-        </p:nvSpPr>
-        <p:spPr/>
-        <p:txBody>
-          <a:bodyPr/>
-          <a:lstStyle/>
-          <a:p>
-            <a:r>
-              <a:rPr lang="en-US" dirty="0"/>
-              <a:t>Q6</a:t>
-            </a:r>
-          </a:p>
-        </p:txBody>
-      </p:sp>
-      <p:sp>
-        <p:nvSpPr>
-          <p:cNvPr id="6" name="Content Placeholder 5">
-            <a:extLst>
-              <a:ext uri="{FF2B5EF4-FFF2-40B4-BE49-F238E27FC236}">
-                <a16:creationId xmlns:a16="http://schemas.microsoft.com/office/drawing/2014/main" id="{2EF9F847-1D46-C17E-05CA-C013095844DE}"/>
-              </a:ext>
-            </a:extLst>
-          </p:cNvPr>
-          <p:cNvSpPr>
-            <a:spLocks noGrp="1"/>
-          </p:cNvSpPr>
+          <p:cNvGraphicFramePr>
+            <a:graphicFrameLocks noGrp="1"/>
+          </p:cNvGraphicFramePr>
           <p:nvPr>
             <p:ph sz="quarter" idx="4"/>
+            <p:extLst>
+              <p:ext uri="{D42A27DB-BD31-4B8C-83A1-F6EECF244321}">
+                <p14:modId xmlns:p14="http://schemas.microsoft.com/office/powerpoint/2010/main" val="3837129516"/>
+              </p:ext>
+            </p:extLst>
           </p:nvPr>
-        </p:nvSpPr>
-        <p:spPr/>
-        <p:txBody>
-          <a:bodyPr/>
-          <a:lstStyle/>
-          <a:p>
-            <a:r>
-              <a:rPr lang="en-US" dirty="0"/>
-              <a:t>TODO</a:t>
-            </a:r>
-          </a:p>
-        </p:txBody>
-      </p:sp>
+        </p:nvGraphicFramePr>
+        <p:xfrm>
+          <a:off x="5292991" y="1773236"/>
+          <a:ext cx="5874881" cy="4614864"/>
+        </p:xfrm>
+        <a:graphic>
+          <a:graphicData uri="http://schemas.openxmlformats.org/drawingml/2006/chart">
+            <c:chart xmlns:c="http://schemas.openxmlformats.org/drawingml/2006/chart" xmlns:r="http://schemas.openxmlformats.org/officeDocument/2006/relationships" r:id="rId2"/>
+          </a:graphicData>
+        </a:graphic>
+      </p:graphicFrame>
     </p:spTree>
     <p:extLst>
       <p:ext uri="{BB962C8B-B14F-4D97-AF65-F5344CB8AC3E}">
-        <p14:creationId xmlns:p14="http://schemas.microsoft.com/office/powerpoint/2010/main" val="296423964"/>
-      </p:ext>
-    </p:extLst>
-  </p:cSld>
-  <p:clrMapOvr>
-    <a:masterClrMapping/>
-  </p:clrMapOvr>
-</p:sld>
-</file>
-
-<file path=ppt/slides/slide9.xml><?xml version="1.0" encoding="utf-8"?>
-<p:sld xmlns:a="http://schemas.openxmlformats.org/drawingml/2006/main" xmlns:r="http://schemas.openxmlformats.org/officeDocument/2006/relationships" xmlns:p="http://schemas.openxmlformats.org/presentationml/2006/main">
-  <p:cSld>
-    <p:spTree>
-      <p:nvGrpSpPr>
-        <p:cNvPr id="1" name=""/>
-        <p:cNvGrpSpPr/>
-        <p:nvPr/>
-      </p:nvGrpSpPr>
-      <p:grpSpPr>
-        <a:xfrm>
-          <a:off x="0" y="0"/>
-          <a:ext cx="0" cy="0"/>
-          <a:chOff x="0" y="0"/>
-          <a:chExt cx="0" cy="0"/>
-        </a:xfrm>
-      </p:grpSpPr>
-      <p:sp>
-        <p:nvSpPr>
-          <p:cNvPr id="2" name="Title 1">
-            <a:extLst>
-              <a:ext uri="{FF2B5EF4-FFF2-40B4-BE49-F238E27FC236}">
-                <a16:creationId xmlns:a16="http://schemas.microsoft.com/office/drawing/2014/main" id="{F9406560-2801-DF72-748D-88EA669A4A43}"/>
-              </a:ext>
-            </a:extLst>
-          </p:cNvPr>
-          <p:cNvSpPr>
-            <a:spLocks noGrp="1"/>
-          </p:cNvSpPr>
-          <p:nvPr>
-            <p:ph type="title"/>
-          </p:nvPr>
-        </p:nvSpPr>
-        <p:spPr/>
-        <p:txBody>
-          <a:bodyPr/>
-          <a:lstStyle/>
-          <a:p>
-            <a:r>
-              <a:rPr lang="en-US" dirty="0"/>
-              <a:t>Order Insights</a:t>
-            </a:r>
-          </a:p>
-        </p:txBody>
-      </p:sp>
-      <p:sp>
-        <p:nvSpPr>
-          <p:cNvPr id="3" name="Text Placeholder 2">
-            <a:extLst>
-              <a:ext uri="{FF2B5EF4-FFF2-40B4-BE49-F238E27FC236}">
-                <a16:creationId xmlns:a16="http://schemas.microsoft.com/office/drawing/2014/main" id="{BF3F6C46-87BA-B4DA-4388-4B98932BFA35}"/>
-              </a:ext>
-            </a:extLst>
-          </p:cNvPr>
-          <p:cNvSpPr>
-            <a:spLocks noGrp="1"/>
-          </p:cNvSpPr>
-          <p:nvPr>
-            <p:ph type="body" idx="1"/>
-          </p:nvPr>
-        </p:nvSpPr>
-        <p:spPr/>
-        <p:txBody>
-          <a:bodyPr/>
-          <a:lstStyle/>
-          <a:p>
-            <a:r>
-              <a:rPr lang="en-US" dirty="0"/>
-              <a:t>Q7</a:t>
-            </a:r>
-          </a:p>
-        </p:txBody>
-      </p:sp>
-      <p:sp>
-        <p:nvSpPr>
-          <p:cNvPr id="4" name="Content Placeholder 3">
-            <a:extLst>
-              <a:ext uri="{FF2B5EF4-FFF2-40B4-BE49-F238E27FC236}">
-                <a16:creationId xmlns:a16="http://schemas.microsoft.com/office/drawing/2014/main" id="{3A9AED6A-86DC-694C-C636-2D6D387EEB7D}"/>
-              </a:ext>
-            </a:extLst>
-          </p:cNvPr>
-          <p:cNvSpPr>
-            <a:spLocks noGrp="1"/>
-          </p:cNvSpPr>
-          <p:nvPr>
-            <p:ph sz="half" idx="2"/>
-          </p:nvPr>
-        </p:nvSpPr>
-        <p:spPr/>
-        <p:txBody>
-          <a:bodyPr/>
-          <a:lstStyle/>
-          <a:p>
-            <a:r>
-              <a:rPr lang="en-US" dirty="0"/>
-              <a:t>TODO</a:t>
-            </a:r>
-          </a:p>
-        </p:txBody>
-      </p:sp>
-      <p:sp>
-        <p:nvSpPr>
-          <p:cNvPr id="5" name="Text Placeholder 4">
-            <a:extLst>
-              <a:ext uri="{FF2B5EF4-FFF2-40B4-BE49-F238E27FC236}">
-                <a16:creationId xmlns:a16="http://schemas.microsoft.com/office/drawing/2014/main" id="{5AFE4C2F-7FAD-2628-CE31-14ADE076AB8B}"/>
-              </a:ext>
-            </a:extLst>
-          </p:cNvPr>
-          <p:cNvSpPr>
-            <a:spLocks noGrp="1"/>
-          </p:cNvSpPr>
-          <p:nvPr>
-            <p:ph type="body" sz="quarter" idx="3"/>
-          </p:nvPr>
-        </p:nvSpPr>
-        <p:spPr/>
-        <p:txBody>
-          <a:bodyPr/>
-          <a:lstStyle/>
-          <a:p>
-            <a:r>
-              <a:rPr lang="en-US" dirty="0"/>
-              <a:t>Q8</a:t>
-            </a:r>
-          </a:p>
-        </p:txBody>
-      </p:sp>
-      <p:sp>
-        <p:nvSpPr>
-          <p:cNvPr id="6" name="Content Placeholder 5">
-            <a:extLst>
-              <a:ext uri="{FF2B5EF4-FFF2-40B4-BE49-F238E27FC236}">
-                <a16:creationId xmlns:a16="http://schemas.microsoft.com/office/drawing/2014/main" id="{86BFE0CA-2E02-792F-8BE4-233204DDE9A5}"/>
-              </a:ext>
-            </a:extLst>
-          </p:cNvPr>
-          <p:cNvSpPr>
-            <a:spLocks noGrp="1"/>
-          </p:cNvSpPr>
-          <p:nvPr>
-            <p:ph sz="quarter" idx="4"/>
-          </p:nvPr>
-        </p:nvSpPr>
-        <p:spPr/>
-        <p:txBody>
-          <a:bodyPr/>
-          <a:lstStyle/>
-          <a:p>
-            <a:r>
-              <a:rPr lang="en-US" dirty="0"/>
-              <a:t>TODO</a:t>
-            </a:r>
-          </a:p>
-        </p:txBody>
-      </p:sp>
-    </p:spTree>
-    <p:extLst>
-      <p:ext uri="{BB962C8B-B14F-4D97-AF65-F5344CB8AC3E}">
-        <p14:creationId xmlns:p14="http://schemas.microsoft.com/office/powerpoint/2010/main" val="3907987761"/>
+        <p14:creationId xmlns:p14="http://schemas.microsoft.com/office/powerpoint/2010/main" val="1186552766"/>
       </p:ext>
     </p:extLst>
   </p:cSld>

</xml_diff>

<commit_message>
App, presentation, readme update
</commit_message>
<xml_diff>
--- a/presentation/Olist E-Commerce Analysis.pptx
+++ b/presentation/Olist E-Commerce Analysis.pptx
@@ -27,8 +27,9 @@
     <p:sldId id="272" r:id="rId21"/>
     <p:sldId id="275" r:id="rId22"/>
     <p:sldId id="276" r:id="rId23"/>
-    <p:sldId id="273" r:id="rId24"/>
-    <p:sldId id="274" r:id="rId25"/>
+    <p:sldId id="281" r:id="rId24"/>
+    <p:sldId id="273" r:id="rId25"/>
+    <p:sldId id="274" r:id="rId26"/>
   </p:sldIdLst>
   <p:sldSz cx="12192000" cy="6858000"/>
   <p:notesSz cx="6858000" cy="9144000"/>
@@ -10601,7 +10602,7 @@
           <a:p>
             <a:fld id="{B2374077-9B34-4FA8-8422-634E903F67E1}" type="datetimeFigureOut">
               <a:rPr lang="en-US" smtClean="0"/>
-              <a:t>4/19/2026</a:t>
+              <a:t>4/23/2026</a:t>
             </a:fld>
             <a:endParaRPr lang="en-US"/>
           </a:p>
@@ -10808,7 +10809,7 @@
           <a:p>
             <a:fld id="{B2374077-9B34-4FA8-8422-634E903F67E1}" type="datetimeFigureOut">
               <a:rPr lang="en-US" smtClean="0"/>
-              <a:t>4/19/2026</a:t>
+              <a:t>4/23/2026</a:t>
             </a:fld>
             <a:endParaRPr lang="en-US"/>
           </a:p>
@@ -10988,7 +10989,7 @@
           <a:p>
             <a:fld id="{B2374077-9B34-4FA8-8422-634E903F67E1}" type="datetimeFigureOut">
               <a:rPr lang="en-US" smtClean="0"/>
-              <a:t>4/19/2026</a:t>
+              <a:t>4/23/2026</a:t>
             </a:fld>
             <a:endParaRPr lang="en-US"/>
           </a:p>
@@ -11193,7 +11194,7 @@
           <a:p>
             <a:fld id="{B2374077-9B34-4FA8-8422-634E903F67E1}" type="datetimeFigureOut">
               <a:rPr lang="en-US" smtClean="0"/>
-              <a:t>4/19/2026</a:t>
+              <a:t>4/23/2026</a:t>
             </a:fld>
             <a:endParaRPr lang="en-US"/>
           </a:p>
@@ -20105,7 +20106,7 @@
           <a:p>
             <a:fld id="{B2374077-9B34-4FA8-8422-634E903F67E1}" type="datetimeFigureOut">
               <a:rPr lang="en-US" smtClean="0"/>
-              <a:t>4/19/2026</a:t>
+              <a:t>4/23/2026</a:t>
             </a:fld>
             <a:endParaRPr lang="en-US"/>
           </a:p>
@@ -20379,7 +20380,7 @@
           <a:p>
             <a:fld id="{B2374077-9B34-4FA8-8422-634E903F67E1}" type="datetimeFigureOut">
               <a:rPr lang="en-US" smtClean="0"/>
-              <a:t>4/19/2026</a:t>
+              <a:t>4/23/2026</a:t>
             </a:fld>
             <a:endParaRPr lang="en-US"/>
           </a:p>
@@ -20777,7 +20778,7 @@
           <a:p>
             <a:fld id="{B2374077-9B34-4FA8-8422-634E903F67E1}" type="datetimeFigureOut">
               <a:rPr lang="en-US" smtClean="0"/>
-              <a:t>4/19/2026</a:t>
+              <a:t>4/23/2026</a:t>
             </a:fld>
             <a:endParaRPr lang="en-US"/>
           </a:p>
@@ -20895,7 +20896,7 @@
           <a:p>
             <a:fld id="{B2374077-9B34-4FA8-8422-634E903F67E1}" type="datetimeFigureOut">
               <a:rPr lang="en-US" smtClean="0"/>
-              <a:t>4/19/2026</a:t>
+              <a:t>4/23/2026</a:t>
             </a:fld>
             <a:endParaRPr lang="en-US"/>
           </a:p>
@@ -20990,7 +20991,7 @@
           <a:p>
             <a:fld id="{B2374077-9B34-4FA8-8422-634E903F67E1}" type="datetimeFigureOut">
               <a:rPr lang="en-US" smtClean="0"/>
-              <a:t>4/19/2026</a:t>
+              <a:t>4/23/2026</a:t>
             </a:fld>
             <a:endParaRPr lang="en-US"/>
           </a:p>
@@ -21280,7 +21281,7 @@
           <a:p>
             <a:fld id="{B2374077-9B34-4FA8-8422-634E903F67E1}" type="datetimeFigureOut">
               <a:rPr lang="en-US" smtClean="0"/>
-              <a:t>4/19/2026</a:t>
+              <a:t>4/23/2026</a:t>
             </a:fld>
             <a:endParaRPr lang="en-US"/>
           </a:p>
@@ -21560,7 +21561,7 @@
           <a:p>
             <a:fld id="{B2374077-9B34-4FA8-8422-634E903F67E1}" type="datetimeFigureOut">
               <a:rPr lang="en-US" smtClean="0"/>
-              <a:t>4/19/2026</a:t>
+              <a:t>4/23/2026</a:t>
             </a:fld>
             <a:endParaRPr lang="en-US"/>
           </a:p>
@@ -21810,7 +21811,7 @@
           <a:p>
             <a:fld id="{B2374077-9B34-4FA8-8422-634E903F67E1}" type="datetimeFigureOut">
               <a:rPr lang="en-US" smtClean="0"/>
-              <a:t>4/19/2026</a:t>
+              <a:t>4/23/2026</a:t>
             </a:fld>
             <a:endParaRPr lang="en-US"/>
           </a:p>
@@ -25683,6 +25684,102 @@
       </p:grpSpPr>
       <p:sp>
         <p:nvSpPr>
+          <p:cNvPr id="2" name="Title 1">
+            <a:extLst>
+              <a:ext uri="{FF2B5EF4-FFF2-40B4-BE49-F238E27FC236}">
+                <a16:creationId xmlns:a16="http://schemas.microsoft.com/office/drawing/2014/main" id="{09188226-AC94-9FAF-FD4C-1973CFA7526A}"/>
+              </a:ext>
+            </a:extLst>
+          </p:cNvPr>
+          <p:cNvSpPr>
+            <a:spLocks noGrp="1"/>
+          </p:cNvSpPr>
+          <p:nvPr>
+            <p:ph type="title"/>
+          </p:nvPr>
+        </p:nvSpPr>
+        <p:spPr/>
+        <p:txBody>
+          <a:bodyPr/>
+          <a:lstStyle/>
+          <a:p>
+            <a:r>
+              <a:rPr lang="en-US" dirty="0"/>
+              <a:t>Interactive MAP</a:t>
+            </a:r>
+          </a:p>
+        </p:txBody>
+      </p:sp>
+      <p:sp>
+        <p:nvSpPr>
+          <p:cNvPr id="3" name="Content Placeholder 2">
+            <a:extLst>
+              <a:ext uri="{FF2B5EF4-FFF2-40B4-BE49-F238E27FC236}">
+                <a16:creationId xmlns:a16="http://schemas.microsoft.com/office/drawing/2014/main" id="{CD6AFC73-E333-4AEC-00E1-2072804FC6FC}"/>
+              </a:ext>
+            </a:extLst>
+          </p:cNvPr>
+          <p:cNvSpPr>
+            <a:spLocks noGrp="1"/>
+          </p:cNvSpPr>
+          <p:nvPr>
+            <p:ph idx="1"/>
+          </p:nvPr>
+        </p:nvSpPr>
+        <p:spPr/>
+        <p:txBody>
+          <a:bodyPr>
+            <a:normAutofit/>
+          </a:bodyPr>
+          <a:lstStyle/>
+          <a:p>
+            <a:pPr algn="ctr"/>
+            <a:endParaRPr lang="en-US" sz="4400" dirty="0"/>
+          </a:p>
+          <a:p>
+            <a:pPr algn="ctr"/>
+            <a:r>
+              <a:rPr lang="en-US" sz="4400" dirty="0">
+                <a:hlinkClick r:id="rId2"/>
+              </a:rPr>
+              <a:t>https://olist-db.netlify.app/</a:t>
+            </a:r>
+            <a:endParaRPr lang="en-US" sz="4400" dirty="0"/>
+          </a:p>
+        </p:txBody>
+      </p:sp>
+    </p:spTree>
+    <p:extLst>
+      <p:ext uri="{BB962C8B-B14F-4D97-AF65-F5344CB8AC3E}">
+        <p14:creationId xmlns:p14="http://schemas.microsoft.com/office/powerpoint/2010/main" val="3520607905"/>
+      </p:ext>
+    </p:extLst>
+  </p:cSld>
+  <p:clrMapOvr>
+    <a:masterClrMapping/>
+  </p:clrMapOvr>
+</p:sld>
+</file>
+
+<file path=ppt/slides/slide24.xml><?xml version="1.0" encoding="utf-8"?>
+<p:sld xmlns:a="http://schemas.openxmlformats.org/drawingml/2006/main" xmlns:r="http://schemas.openxmlformats.org/officeDocument/2006/relationships" xmlns:p="http://schemas.openxmlformats.org/presentationml/2006/main">
+  <p:cSld>
+    <p:spTree>
+      <p:nvGrpSpPr>
+        <p:cNvPr id="1" name=""/>
+        <p:cNvGrpSpPr/>
+        <p:nvPr/>
+      </p:nvGrpSpPr>
+      <p:grpSpPr>
+        <a:xfrm>
+          <a:off x="0" y="0"/>
+          <a:ext cx="0" cy="0"/>
+          <a:chOff x="0" y="0"/>
+          <a:chExt cx="0" cy="0"/>
+        </a:xfrm>
+      </p:grpSpPr>
+      <p:sp>
+        <p:nvSpPr>
           <p:cNvPr id="3" name="Title 2">
             <a:extLst>
               <a:ext uri="{FF2B5EF4-FFF2-40B4-BE49-F238E27FC236}">
@@ -25777,7 +25874,7 @@
 </p:sld>
 </file>
 
-<file path=ppt/slides/slide24.xml><?xml version="1.0" encoding="utf-8"?>
+<file path=ppt/slides/slide25.xml><?xml version="1.0" encoding="utf-8"?>
 <p:sld xmlns:a="http://schemas.openxmlformats.org/drawingml/2006/main" xmlns:r="http://schemas.openxmlformats.org/officeDocument/2006/relationships" xmlns:p="http://schemas.openxmlformats.org/presentationml/2006/main">
   <p:cSld>
     <p:spTree>

</xml_diff>